<commit_message>
Add enterprise valuation slides (25-26)
Adds a two-lens valuation argument: slide 25 contrasts the book value
of hard assets (P&M ~90% depreciated to ~₹1.8 Cr, land at ~₹0.79 Cr
historical cost, FY25 net worth of -₹1.54 Cr) against illustrative
capitalized-earnings value off the 3-year average audited PAT, showing
even light multiples clear 3x+ the fixed-asset book. Slide 26 frames
why the gap doesn't collapse into an easy open-market sale (thin pool
of buyers who can underwrite the qualification/relationship moat vs.
a generic asset buyer) and recommends negotiating on earnings capacity
plus strategic premium rather than NAV. Renumbers slides 25-26 to
27-28 and updates the internal cross-reference accordingly.

Co-Authored-By: Claude Sonnet 5 <noreply@anthropic.com>
Claude-Session: https://claude.ai/code/session_01KAt6XMpnq79QzphizNAsgo
</commit_message>
<xml_diff>
--- a/investor-pitch/Datre_Corporation_Investor_Pitch.pptx
+++ b/investor-pitch/Datre_Corporation_Investor_Pitch.pptx
@@ -31,9 +31,11 @@
     <p:sldId id="279" r:id="rId25"/>
     <p:sldId id="280" r:id="rId26"/>
     <p:sldId id="281" r:id="rId27"/>
+    <p:sldId id="282" r:id="rId28"/>
+    <p:sldId id="283" r:id="rId29"/>
   </p:sldIdLst>
   <p:notesMasterIdLst>
-    <p:notesMasterId r:id="rId28"/>
+    <p:notesMasterId r:id="rId30"/>
   </p:notesMasterIdLst>
   <p:sldSz cx="12191695" cy="6858000"/>
   <p:notesSz cx="6858000" cy="12191695"/>
@@ -2786,6 +2788,353 @@
 </c:chartSpace>
 </file>
 
+<file path=ppt/charts/chart9.xml><?xml version="1.0" encoding="utf-8"?>
+<c:chartSpace xmlns:c="http://schemas.openxmlformats.org/drawingml/2006/chart" xmlns:a="http://schemas.openxmlformats.org/drawingml/2006/main" xmlns:r="http://schemas.openxmlformats.org/officeDocument/2006/relationships">
+  <c:date1904 val="0"/>
+  <c:roundedCorners val="1"/>
+  <c:chart>
+    <c:autoTitleDeleted val="1"/>
+    <c:plotArea>
+      <c:layout/>
+      <c:barChart>
+        <c:barDir val="col"/>
+        <c:grouping val="clustered"/>
+        <c:varyColors val="0"/>
+        <c:ser>
+          <c:idx val="0"/>
+          <c:order val="0"/>
+          <c:tx>
+            <c:strRef>
+              <c:f>Sheet1!$B$1</c:f>
+              <c:strCache>
+                <c:ptCount val="1"/>
+                <c:pt idx="0">
+                  <c:v>₹ Cr</c:v>
+                </c:pt>
+              </c:strCache>
+            </c:strRef>
+          </c:tx>
+          <c:spPr>
+            <a:solidFill>
+              <a:srgbClr val="6B7684"/>
+            </a:solidFill>
+            <a:effectLst/>
+          </c:spPr>
+          <c:invertIfNegative val="0"/>
+          <c:dLbls>
+            <c:numFmt formatCode="0.00" sourceLinked="0"/>
+            <c:txPr>
+              <a:bodyPr/>
+              <a:lstStyle/>
+              <a:p>
+                <a:pPr>
+                  <a:defRPr b="0" i="0" strike="noStrike" sz="1050" u="none">
+                    <a:solidFill>
+                      <a:srgbClr val="1C1F26"/>
+                    </a:solidFill>
+                    <a:latin typeface="Arial"/>
+                  </a:defRPr>
+                </a:pPr>
+              </a:p>
+            </c:txPr>
+            <c:showLegendKey val="0"/>
+            <c:showVal val="1"/>
+            <c:showCatName val="0"/>
+            <c:showSerName val="0"/>
+            <c:showPercent val="0"/>
+            <c:showBubbleSize val="0"/>
+            <c:showLeaderLines val="0"/>
+          </c:dLbls>
+          <c:dPt>
+            <c:idx val="0"/>
+            <c:invertIfNegative val="0"/>
+            <c:bubble3D val="0"/>
+            <c:spPr>
+              <a:solidFill>
+                <a:srgbClr val="6B7684"/>
+              </a:solidFill>
+              <a:effectLst/>
+            </c:spPr>
+          </c:dPt>
+          <c:dPt>
+            <c:idx val="1"/>
+            <c:invertIfNegative val="0"/>
+            <c:bubble3D val="0"/>
+            <c:spPr>
+              <a:solidFill>
+                <a:srgbClr val="6B7684"/>
+              </a:solidFill>
+              <a:effectLst/>
+            </c:spPr>
+          </c:dPt>
+          <c:dPt>
+            <c:idx val="2"/>
+            <c:invertIfNegative val="0"/>
+            <c:bubble3D val="0"/>
+            <c:spPr>
+              <a:solidFill>
+                <a:srgbClr val="D9622B"/>
+              </a:solidFill>
+              <a:effectLst/>
+            </c:spPr>
+          </c:dPt>
+          <c:dPt>
+            <c:idx val="3"/>
+            <c:invertIfNegative val="0"/>
+            <c:bubble3D val="0"/>
+            <c:spPr>
+              <a:solidFill>
+                <a:srgbClr val="D9622B"/>
+              </a:solidFill>
+              <a:effectLst/>
+            </c:spPr>
+          </c:dPt>
+          <c:dPt>
+            <c:idx val="4"/>
+            <c:invertIfNegative val="0"/>
+            <c:bubble3D val="0"/>
+            <c:spPr>
+              <a:solidFill>
+                <a:srgbClr val="D9622B"/>
+              </a:solidFill>
+              <a:effectLst/>
+            </c:spPr>
+          </c:dPt>
+          <c:cat>
+            <c:multiLvlStrRef>
+              <c:f>Sheet1!$A$2:$A$6</c:f>
+              <c:multiLvlStrCache>
+                <c:ptCount val="5"/>
+                <c:lvl>
+                  <c:pt idx="0">
+                    <c:v>P&amp;M net book
+value</c:v>
+                  </c:pt>
+                  <c:pt idx="1">
+                    <c:v>Land
+(historical cost)</c:v>
+                  </c:pt>
+                  <c:pt idx="2">
+                    <c:v>FMV @ 4x
+avg. PAT</c:v>
+                  </c:pt>
+                  <c:pt idx="3">
+                    <c:v>FMV @ 6x
+avg. PAT</c:v>
+                  </c:pt>
+                  <c:pt idx="4">
+                    <c:v>FMV @ 8x
+avg. PAT</c:v>
+                  </c:pt>
+                </c:lvl>
+              </c:multiLvlStrCache>
+            </c:multiLvlStrRef>
+          </c:cat>
+          <c:val>
+            <c:numRef>
+              <c:f>Sheet1!$B$2:$B$6</c:f>
+              <c:numCache>
+                <c:formatCode>General</c:formatCode>
+                <c:ptCount val="5"/>
+                <c:pt idx="0">
+                  <c:v>1.8</c:v>
+                </c:pt>
+                <c:pt idx="1">
+                  <c:v>0.79</c:v>
+                </c:pt>
+                <c:pt idx="2">
+                  <c:v>5.7</c:v>
+                </c:pt>
+                <c:pt idx="3">
+                  <c:v>8.6</c:v>
+                </c:pt>
+                <c:pt idx="4">
+                  <c:v>11.4</c:v>
+                </c:pt>
+              </c:numCache>
+            </c:numRef>
+          </c:val>
+        </c:ser>
+        <c:dLbls>
+          <c:numFmt formatCode="0.00" sourceLinked="0"/>
+          <c:txPr>
+            <a:bodyPr/>
+            <a:lstStyle/>
+            <a:p>
+              <a:pPr>
+                <a:defRPr b="0" i="0" strike="noStrike" sz="1050" u="none">
+                  <a:solidFill>
+                    <a:srgbClr val="1C1F26"/>
+                  </a:solidFill>
+                  <a:latin typeface="Arial"/>
+                </a:defRPr>
+              </a:pPr>
+            </a:p>
+          </c:txPr>
+          <c:showLegendKey val="0"/>
+          <c:showVal val="1"/>
+          <c:showCatName val="0"/>
+          <c:showSerName val="0"/>
+          <c:showPercent val="0"/>
+          <c:showBubbleSize val="0"/>
+          <c:showLeaderLines val="0"/>
+        </c:dLbls>
+        <c:gapWidth val="150"/>
+        <c:overlap val="0"/>
+        <c:axId val="2094734554"/>
+        <c:axId val="2094734552"/>
+        <c:axId val="2094734556"/>
+      </c:barChart>
+      <c:catAx>
+        <c:axId val="2094734554"/>
+        <c:scaling>
+          <c:orientation val="minMax"/>
+        </c:scaling>
+        <c:delete val="0"/>
+        <c:axPos val="b"/>
+        <c:numFmt formatCode="General" sourceLinked="1"/>
+        <c:majorTickMark val="out"/>
+        <c:minorTickMark val="none"/>
+        <c:tickLblPos val="low"/>
+        <c:spPr>
+          <a:ln w="12700" cap="flat">
+            <a:solidFill>
+              <a:srgbClr val="888888"/>
+            </a:solidFill>
+            <a:prstDash val="solid"/>
+            <a:round/>
+          </a:ln>
+        </c:spPr>
+        <c:txPr>
+          <a:bodyPr/>
+          <a:lstStyle/>
+          <a:p>
+            <a:pPr>
+              <a:defRPr sz="900" b="0" i="0" u="none" strike="noStrike">
+                <a:solidFill>
+                  <a:srgbClr val="3A4553"/>
+                </a:solidFill>
+                <a:latin typeface="Arial"/>
+              </a:defRPr>
+            </a:pPr>
+            <a:endParaRPr lang="en-US"/>
+          </a:p>
+        </c:txPr>
+        <c:crossAx val="2094734552"/>
+        <c:crosses val="autoZero"/>
+        <c:auto val="1"/>
+        <c:lblAlgn val="ctr"/>
+        <c:noMultiLvlLbl val="1"/>
+      </c:catAx>
+      <c:valAx>
+        <c:axId val="2094734552"/>
+        <c:scaling>
+          <c:orientation val="minMax"/>
+          <c:max val="13"/>
+          <c:min val="0"/>
+        </c:scaling>
+        <c:delete val="0"/>
+        <c:axPos val="l"/>
+        <c:majorGridlines>
+          <c:spPr>
+            <a:ln w="9525" cap="flat">
+              <a:solidFill>
+                <a:srgbClr val="E1E4E9"/>
+              </a:solidFill>
+              <a:prstDash val="solid"/>
+              <a:round/>
+            </a:ln>
+          </c:spPr>
+        </c:majorGridlines>
+        <c:title>
+          <c:tx>
+            <c:rich>
+              <a:bodyPr/>
+              <a:lstStyle/>
+              <a:p>
+                <a:pPr>
+                  <a:defRPr sz="900" b="0" i="0" u="none" strike="noStrike">
+                    <a:solidFill>
+                      <a:srgbClr val="6B7684"/>
+                    </a:solidFill>
+                    <a:latin typeface="Arial"/>
+                  </a:defRPr>
+                </a:pPr>
+                <a:r>
+                  <a:rPr sz="900" b="0" i="0" u="none" strike="noStrike">
+                    <a:solidFill>
+                      <a:srgbClr val="6B7684"/>
+                    </a:solidFill>
+                    <a:latin typeface="Arial"/>
+                  </a:rPr>
+                  <a:t>₹ Cr</a:t>
+                </a:r>
+              </a:p>
+            </c:rich>
+          </c:tx>
+          <c:layout/>
+          <c:overlay val="0"/>
+        </c:title>
+        <c:numFmt formatCode="General" sourceLinked="0"/>
+        <c:majorTickMark val="out"/>
+        <c:minorTickMark val="none"/>
+        <c:tickLblPos val="nextTo"/>
+        <c:spPr>
+          <a:ln w="12700" cap="flat">
+            <a:solidFill>
+              <a:srgbClr val="888888"/>
+            </a:solidFill>
+            <a:prstDash val="solid"/>
+            <a:round/>
+          </a:ln>
+        </c:spPr>
+        <c:txPr>
+          <a:bodyPr/>
+          <a:lstStyle/>
+          <a:p>
+            <a:pPr>
+              <a:defRPr sz="900" b="0" i="0" u="none" strike="noStrike">
+                <a:solidFill>
+                  <a:srgbClr val="3A4553"/>
+                </a:solidFill>
+                <a:latin typeface="Arial"/>
+              </a:defRPr>
+            </a:pPr>
+            <a:endParaRPr lang="en-US"/>
+          </a:p>
+        </c:txPr>
+        <c:crossAx val="2094734554"/>
+        <c:crosses val="autoZero"/>
+        <c:crossBetween val="between"/>
+      </c:valAx>
+      <c:spPr>
+        <a:solidFill>
+          <a:srgbClr val="FFFFFF"/>
+        </a:solidFill>
+        <a:ln>
+          <a:noFill/>
+        </a:ln>
+        <a:effectLst/>
+      </c:spPr>
+    </c:plotArea>
+    <c:plotVisOnly val="1"/>
+    <c:dispBlanksAs val="span"/>
+  </c:chart>
+  <c:spPr>
+    <a:solidFill>
+      <a:srgbClr val="FFFFFF"/>
+    </a:solidFill>
+    <a:ln>
+      <a:noFill/>
+    </a:ln>
+    <a:effectLst/>
+  </c:spPr>
+  <c:externalData r:id="rId1">
+    <c:autoUpdate val="0"/>
+  </c:externalData>
+</c:chartSpace>
+</file>
+
 <file path=ppt/notesMasters/notesMaster1.xml><?xml version="1.0" encoding="utf-8"?>
 <p:notesMaster xmlns:a="http://schemas.openxmlformats.org/drawingml/2006/main" xmlns:r="http://schemas.openxmlformats.org/officeDocument/2006/relationships" xmlns:p="http://schemas.openxmlformats.org/presentationml/2006/main">
   <p:cSld>
@@ -4789,6 +5138,182 @@
             <a:fld id="{F7021451-1387-4CA6-816F-3879F97B5CBC}" type="slidenum">
               <a:rPr lang="en-US"/>
               <a:t>26</a:t>
+            </a:fld>
+            <a:endParaRPr lang="en-US"/>
+          </a:p>
+        </p:txBody>
+      </p:sp>
+    </p:spTree>
+    <p:extLst>
+      <p:ext uri="{BB962C8B-B14F-4D97-AF65-F5344CB8AC3E}">
+        <p14:creationId xmlns:p14="http://schemas.microsoft.com/office/powerpoint/2010/main" val="1024086991"/>
+      </p:ext>
+    </p:extLst>
+  </p:cSld>
+  <p:clrMapOvr>
+    <a:masterClrMapping/>
+  </p:clrMapOvr>
+</p:notes>
+</file>
+
+<file path=ppt/notesSlides/notesSlide27.xml><?xml version="1.0" encoding="utf-8"?>
+<p:notes xmlns:a="http://schemas.openxmlformats.org/drawingml/2006/main" xmlns:r="http://schemas.openxmlformats.org/officeDocument/2006/relationships" xmlns:p="http://schemas.openxmlformats.org/presentationml/2006/main">
+  <p:cSld>
+    <p:spTree>
+      <p:nvGrpSpPr>
+        <p:cNvPr id="1" name=""/>
+        <p:cNvGrpSpPr/>
+        <p:nvPr/>
+      </p:nvGrpSpPr>
+      <p:grpSpPr>
+        <a:xfrm>
+          <a:off x="0" y="0"/>
+          <a:ext cx="0" cy="0"/>
+          <a:chOff x="0" y="0"/>
+          <a:chExt cx="0" cy="0"/>
+        </a:xfrm>
+      </p:grpSpPr>
+      <p:sp>
+        <p:nvSpPr>
+          <p:cNvPr id="2" name="Slide Image Placeholder 1"/>
+          <p:cNvSpPr>
+            <a:spLocks noGrp="1" noRot="1" noChangeAspect="1"/>
+          </p:cNvSpPr>
+          <p:nvPr>
+            <p:ph type="sldImg"/>
+          </p:nvPr>
+        </p:nvSpPr>
+        <p:spPr/>
+      </p:sp>
+      <p:sp>
+        <p:nvSpPr>
+          <p:cNvPr id="3" name="Notes Placeholder 2"/>
+          <p:cNvSpPr>
+            <a:spLocks noGrp="1"/>
+          </p:cNvSpPr>
+          <p:nvPr>
+            <p:ph type="body" idx="1"/>
+          </p:nvPr>
+        </p:nvSpPr>
+        <p:spPr/>
+        <p:txBody>
+          <a:bodyPr/>
+          <a:lstStyle/>
+          <a:p>
+            <a:r>
+              <a:rPr lang="en-US" dirty="0"/>
+              <a:t/>
+            </a:r>
+            <a:endParaRPr lang="en-US" dirty="0"/>
+          </a:p>
+        </p:txBody>
+      </p:sp>
+      <p:sp>
+        <p:nvSpPr>
+          <p:cNvPr id="4" name="Slide Number Placeholder 3"/>
+          <p:cNvSpPr>
+            <a:spLocks noGrp="1"/>
+          </p:cNvSpPr>
+          <p:nvPr>
+            <p:ph type="sldNum" sz="quarter" idx="10"/>
+          </p:nvPr>
+        </p:nvSpPr>
+        <p:spPr/>
+        <p:txBody>
+          <a:bodyPr/>
+          <a:lstStyle/>
+          <a:p>
+            <a:fld id="{F7021451-1387-4CA6-816F-3879F97B5CBC}" type="slidenum">
+              <a:rPr lang="en-US"/>
+              <a:t>27</a:t>
+            </a:fld>
+            <a:endParaRPr lang="en-US"/>
+          </a:p>
+        </p:txBody>
+      </p:sp>
+    </p:spTree>
+    <p:extLst>
+      <p:ext uri="{BB962C8B-B14F-4D97-AF65-F5344CB8AC3E}">
+        <p14:creationId xmlns:p14="http://schemas.microsoft.com/office/powerpoint/2010/main" val="1024086991"/>
+      </p:ext>
+    </p:extLst>
+  </p:cSld>
+  <p:clrMapOvr>
+    <a:masterClrMapping/>
+  </p:clrMapOvr>
+</p:notes>
+</file>
+
+<file path=ppt/notesSlides/notesSlide28.xml><?xml version="1.0" encoding="utf-8"?>
+<p:notes xmlns:a="http://schemas.openxmlformats.org/drawingml/2006/main" xmlns:r="http://schemas.openxmlformats.org/officeDocument/2006/relationships" xmlns:p="http://schemas.openxmlformats.org/presentationml/2006/main">
+  <p:cSld>
+    <p:spTree>
+      <p:nvGrpSpPr>
+        <p:cNvPr id="1" name=""/>
+        <p:cNvGrpSpPr/>
+        <p:nvPr/>
+      </p:nvGrpSpPr>
+      <p:grpSpPr>
+        <a:xfrm>
+          <a:off x="0" y="0"/>
+          <a:ext cx="0" cy="0"/>
+          <a:chOff x="0" y="0"/>
+          <a:chExt cx="0" cy="0"/>
+        </a:xfrm>
+      </p:grpSpPr>
+      <p:sp>
+        <p:nvSpPr>
+          <p:cNvPr id="2" name="Slide Image Placeholder 1"/>
+          <p:cNvSpPr>
+            <a:spLocks noGrp="1" noRot="1" noChangeAspect="1"/>
+          </p:cNvSpPr>
+          <p:nvPr>
+            <p:ph type="sldImg"/>
+          </p:nvPr>
+        </p:nvSpPr>
+        <p:spPr/>
+      </p:sp>
+      <p:sp>
+        <p:nvSpPr>
+          <p:cNvPr id="3" name="Notes Placeholder 2"/>
+          <p:cNvSpPr>
+            <a:spLocks noGrp="1"/>
+          </p:cNvSpPr>
+          <p:nvPr>
+            <p:ph type="body" idx="1"/>
+          </p:nvPr>
+        </p:nvSpPr>
+        <p:spPr/>
+        <p:txBody>
+          <a:bodyPr/>
+          <a:lstStyle/>
+          <a:p>
+            <a:r>
+              <a:rPr lang="en-US" dirty="0"/>
+              <a:t/>
+            </a:r>
+            <a:endParaRPr lang="en-US" dirty="0"/>
+          </a:p>
+        </p:txBody>
+      </p:sp>
+      <p:sp>
+        <p:nvSpPr>
+          <p:cNvPr id="4" name="Slide Number Placeholder 3"/>
+          <p:cNvSpPr>
+            <a:spLocks noGrp="1"/>
+          </p:cNvSpPr>
+          <p:nvPr>
+            <p:ph type="sldNum" sz="quarter" idx="10"/>
+          </p:nvPr>
+        </p:nvSpPr>
+        <p:spPr/>
+        <p:txBody>
+          <a:bodyPr/>
+          <a:lstStyle/>
+          <a:p>
+            <a:fld id="{F7021451-1387-4CA6-816F-3879F97B5CBC}" type="slidenum">
+              <a:rPr lang="en-US"/>
+              <a:t>28</a:t>
             </a:fld>
             <a:endParaRPr lang="en-US"/>
           </a:p>
@@ -21737,7 +22262,7 @@
     <p:bg>
       <p:bgPr>
         <a:solidFill>
-          <a:srgbClr val="1C1F26"/>
+          <a:srgbClr val="FFFFFF"/>
         </a:solidFill>
       </p:bgPr>
     </p:bg>
@@ -21788,7 +22313,7 @@
                 <a:ea typeface="Calibri" pitchFamily="34" charset="-122"/>
                 <a:cs typeface="Calibri" pitchFamily="34" charset="-120"/>
               </a:rPr>
-              <a:t>INVESTMENT CONSIDERATIONS</a:t>
+              <a:t>VALUATION — THE TWO LENSES</a:t>
             </a:r>
             <a:endParaRPr lang="en-US" sz="1100" dirty="0"/>
           </a:p>
@@ -21821,50 +22346,44 @@
             <a:r>
               <a:rPr lang="en-US" sz="3000" b="1" dirty="0">
                 <a:solidFill>
-                  <a:srgbClr val="FFFFFF"/>
+                  <a:srgbClr val="1C1F26"/>
                 </a:solidFill>
                 <a:latin typeface="Cambria" pitchFamily="34" charset="0"/>
                 <a:ea typeface="Cambria" pitchFamily="34" charset="-122"/>
                 <a:cs typeface="Cambria" pitchFamily="34" charset="-120"/>
               </a:rPr>
-              <a:t>A framework for the ask — terms to be finalized with management</a:t>
+              <a:t>Two ways to price this business — and they disagree by 3-10x</a:t>
             </a:r>
             <a:endParaRPr lang="en-US" sz="3000" dirty="0"/>
           </a:p>
         </p:txBody>
       </p:sp>
-      <p:sp>
-        <p:nvSpPr>
-          <p:cNvPr id="4" name="Shape 2"/>
-          <p:cNvSpPr/>
-          <p:nvPr/>
-        </p:nvSpPr>
-        <p:spPr>
-          <a:xfrm>
-            <a:off x="548640" y="1783080"/>
-            <a:ext cx="11094415" cy="685800"/>
-          </a:xfrm>
-          <a:prstGeom prst="roundRect">
-            <a:avLst>
-              <a:gd name="adj" fmla="val 8000"/>
-            </a:avLst>
-          </a:prstGeom>
-          <a:solidFill>
-            <a:srgbClr val="262B34"/>
-          </a:solidFill>
-          <a:ln/>
-        </p:spPr>
-      </p:sp>
-      <p:sp>
-        <p:nvSpPr>
-          <p:cNvPr id="5" name="Text 3"/>
-          <p:cNvSpPr/>
-          <p:nvPr/>
-        </p:nvSpPr>
-        <p:spPr>
-          <a:xfrm>
-            <a:off x="777240" y="1783080"/>
-            <a:ext cx="10637215" cy="685800"/>
+      <p:graphicFrame>
+        <p:nvGraphicFramePr>
+          <p:cNvPr id="4" name="Chart 0" descr=""/>
+          <p:cNvGraphicFramePr/>
+          <p:nvPr/>
+        </p:nvGraphicFramePr>
+        <p:xfrm>
+          <a:off x="548640" y="1737360"/>
+          <a:ext cx="6400800" cy="3200400"/>
+        </p:xfrm>
+        <a:graphic xmlns:a="http://schemas.openxmlformats.org/drawingml/2006/main">
+          <a:graphicData uri="http://schemas.openxmlformats.org/drawingml/2006/chart">
+            <c:chart xmlns:c="http://schemas.openxmlformats.org/drawingml/2006/chart" r:id="rId1"/>
+          </a:graphicData>
+        </a:graphic>
+      </p:graphicFrame>
+      <p:sp>
+        <p:nvSpPr>
+          <p:cNvPr id="5" name="Text 2"/>
+          <p:cNvSpPr/>
+          <p:nvPr/>
+        </p:nvSpPr>
+        <p:spPr>
+          <a:xfrm>
+            <a:off x="548640" y="5074920"/>
+            <a:ext cx="6400800" cy="594360"/>
           </a:xfrm>
           <a:prstGeom prst="rect">
             <a:avLst/>
@@ -21883,89 +22402,30 @@
               <a:buNone/>
             </a:pPr>
             <a:r>
-              <a:rPr lang="en-US" sz="1030" i="1" dirty="0">
-                <a:solidFill>
-                  <a:srgbClr val="E8B84B"/>
-                </a:solidFill>
-                <a:latin typeface="Calibri" pitchFamily="34" charset="0"/>
-                <a:ea typeface="Calibri" pitchFamily="34" charset="-122"/>
-                <a:cs typeface="Calibri" pitchFamily="34" charset="-120"/>
-              </a:rPr>
-              <a:t>The materials reviewed do not specify a funding quantum, instrument, valuation or use-of-proceeds. What follows is a suggested framework, derived from the financial and operational analysis in this deck — not a management-approved ask.</a:t>
-            </a:r>
-            <a:endParaRPr lang="en-US" sz="1030" dirty="0"/>
-          </a:p>
-        </p:txBody>
-      </p:sp>
-      <p:sp>
-        <p:nvSpPr>
-          <p:cNvPr id="6" name="Shape 4"/>
-          <p:cNvSpPr/>
-          <p:nvPr/>
-        </p:nvSpPr>
-        <p:spPr>
-          <a:xfrm>
-            <a:off x="548640" y="2788920"/>
-            <a:ext cx="457200" cy="457200"/>
-          </a:xfrm>
-          <a:prstGeom prst="ellipse">
-            <a:avLst/>
-          </a:prstGeom>
-          <a:solidFill>
-            <a:srgbClr val="D9622B"/>
-          </a:solidFill>
-          <a:ln/>
-        </p:spPr>
-      </p:sp>
-      <p:sp>
-        <p:nvSpPr>
-          <p:cNvPr id="7" name="Text 5"/>
-          <p:cNvSpPr/>
-          <p:nvPr/>
-        </p:nvSpPr>
-        <p:spPr>
-          <a:xfrm>
-            <a:off x="548640" y="2788920"/>
-            <a:ext cx="457200" cy="457200"/>
-          </a:xfrm>
-          <a:prstGeom prst="rect">
-            <a:avLst/>
-          </a:prstGeom>
-          <a:noFill/>
-          <a:ln/>
-        </p:spPr>
-        <p:txBody>
-          <a:bodyPr wrap="square" lIns="0" tIns="0" rIns="0" bIns="0" rtlCol="0" anchor="ctr"/>
-          <a:lstStyle/>
-          <a:p>
-            <a:pPr algn="ctr" indent="0" marL="0">
-              <a:buNone/>
-            </a:pPr>
-            <a:r>
-              <a:rPr lang="en-US" sz="1300" b="1" dirty="0">
-                <a:solidFill>
-                  <a:srgbClr val="FFFFFF"/>
-                </a:solidFill>
-                <a:latin typeface="Calibri" pitchFamily="34" charset="0"/>
-                <a:ea typeface="Calibri" pitchFamily="34" charset="-122"/>
-                <a:cs typeface="Calibri" pitchFamily="34" charset="-120"/>
-              </a:rPr>
-              <a:t>1</a:t>
-            </a:r>
-            <a:endParaRPr lang="en-US" sz="1300" dirty="0"/>
-          </a:p>
-        </p:txBody>
-      </p:sp>
-      <p:sp>
-        <p:nvSpPr>
-          <p:cNvPr id="8" name="Text 6"/>
-          <p:cNvSpPr/>
-          <p:nvPr/>
-        </p:nvSpPr>
-        <p:spPr>
-          <a:xfrm>
-            <a:off x="1234440" y="2770632"/>
-            <a:ext cx="2926080" cy="502920"/>
+              <a:rPr lang="en-US" sz="850" i="1" dirty="0">
+                <a:solidFill>
+                  <a:srgbClr val="6B7684"/>
+                </a:solidFill>
+                <a:latin typeface="Calibri" pitchFamily="34" charset="0"/>
+                <a:ea typeface="Calibri" pitchFamily="34" charset="-122"/>
+                <a:cs typeface="Calibri" pitchFamily="34" charset="-120"/>
+              </a:rPr>
+              <a:t>Grey bars: today's book value of the hard assets (internal depreciation register, FY23-24 close). Orange bars: illustrative income-basis value, capitalizing the 3-year average audited PAT (₹1.43 Cr, FY23-25) at a range of multiples — no verified comparable transaction exists for Indian niche-foundry M&amp;A; treat as sensitivity, not appraisal.</a:t>
+            </a:r>
+            <a:endParaRPr lang="en-US" sz="850" dirty="0"/>
+          </a:p>
+        </p:txBody>
+      </p:sp>
+      <p:sp>
+        <p:nvSpPr>
+          <p:cNvPr id="6" name="Text 3"/>
+          <p:cNvSpPr/>
+          <p:nvPr/>
+        </p:nvSpPr>
+        <p:spPr>
+          <a:xfrm>
+            <a:off x="7223760" y="1737360"/>
+            <a:ext cx="4419295" cy="411480"/>
           </a:xfrm>
           <a:prstGeom prst="rect">
             <a:avLst/>
@@ -21978,45 +22438,42 @@
           <a:lstStyle/>
           <a:p>
             <a:pPr indent="0" marL="0">
-              <a:lnSpc>
-                <a:spcPct val="100000"/>
-              </a:lnSpc>
-              <a:buNone/>
-            </a:pPr>
-            <a:r>
-              <a:rPr lang="en-US" sz="1300" b="1" dirty="0">
-                <a:solidFill>
-                  <a:srgbClr val="FFFFFF"/>
-                </a:solidFill>
-                <a:latin typeface="Calibri" pitchFamily="34" charset="0"/>
-                <a:ea typeface="Calibri" pitchFamily="34" charset="-122"/>
-                <a:cs typeface="Calibri" pitchFamily="34" charset="-120"/>
-              </a:rPr>
-              <a:t>Balance-sheet repair</a:t>
-            </a:r>
-            <a:endParaRPr lang="en-US" sz="1300" dirty="0"/>
-          </a:p>
-        </p:txBody>
-      </p:sp>
-      <p:sp>
-        <p:nvSpPr>
-          <p:cNvPr id="9" name="Text 7"/>
-          <p:cNvSpPr/>
-          <p:nvPr/>
-        </p:nvSpPr>
-        <p:spPr>
-          <a:xfrm>
-            <a:off x="4297680" y="2743200"/>
-            <a:ext cx="7345375" cy="731520"/>
-          </a:xfrm>
-          <a:prstGeom prst="rect">
-            <a:avLst/>
-          </a:prstGeom>
-          <a:noFill/>
-          <a:ln/>
-        </p:spPr>
-        <p:txBody>
-          <a:bodyPr wrap="square" lIns="0" tIns="0" rIns="0" bIns="0" rtlCol="0" anchor="t"/>
+              <a:buNone/>
+            </a:pPr>
+            <a:r>
+              <a:rPr lang="en-US" sz="2100" b="1" dirty="0">
+                <a:solidFill>
+                  <a:srgbClr val="1C1F26"/>
+                </a:solidFill>
+                <a:latin typeface="Cambria" pitchFamily="34" charset="0"/>
+                <a:ea typeface="Cambria" pitchFamily="34" charset="-122"/>
+                <a:cs typeface="Cambria" pitchFamily="34" charset="-120"/>
+              </a:rPr>
+              <a:t>~90%</a:t>
+            </a:r>
+            <a:endParaRPr lang="en-US" sz="2100" dirty="0"/>
+          </a:p>
+        </p:txBody>
+      </p:sp>
+      <p:sp>
+        <p:nvSpPr>
+          <p:cNvPr id="7" name="Text 4"/>
+          <p:cNvSpPr/>
+          <p:nvPr/>
+        </p:nvSpPr>
+        <p:spPr>
+          <a:xfrm>
+            <a:off x="7223760" y="2139696"/>
+            <a:ext cx="4419295" cy="685800"/>
+          </a:xfrm>
+          <a:prstGeom prst="rect">
+            <a:avLst/>
+          </a:prstGeom>
+          <a:noFill/>
+          <a:ln/>
+        </p:spPr>
+        <p:txBody>
+          <a:bodyPr wrap="square" lIns="0" tIns="0" rIns="0" bIns="0" rtlCol="0" anchor="ctr"/>
           <a:lstStyle/>
           <a:p>
             <a:pPr indent="0" marL="0">
@@ -22026,89 +22483,30 @@
               <a:buNone/>
             </a:pPr>
             <a:r>
-              <a:rPr lang="en-US" sz="1030" dirty="0">
-                <a:solidFill>
-                  <a:srgbClr val="CBD3DC"/>
-                </a:solidFill>
-                <a:latin typeface="Calibri" pitchFamily="34" charset="0"/>
-                <a:ea typeface="Calibri" pitchFamily="34" charset="-122"/>
-                <a:cs typeface="Calibri" pitchFamily="34" charset="-120"/>
-              </a:rPr>
-              <a:t>Equity infusion or a structured plan to accelerate net worth from -₹1.54 Cr (FY25) to positive, rather than relying solely on ~₹1.4 Cr/yr retained earnings.</a:t>
-            </a:r>
-            <a:endParaRPr lang="en-US" sz="1030" dirty="0"/>
-          </a:p>
-        </p:txBody>
-      </p:sp>
-      <p:sp>
-        <p:nvSpPr>
-          <p:cNvPr id="10" name="Shape 8"/>
-          <p:cNvSpPr/>
-          <p:nvPr/>
-        </p:nvSpPr>
-        <p:spPr>
-          <a:xfrm>
-            <a:off x="548640" y="3840480"/>
-            <a:ext cx="457200" cy="457200"/>
-          </a:xfrm>
-          <a:prstGeom prst="ellipse">
-            <a:avLst/>
-          </a:prstGeom>
-          <a:solidFill>
-            <a:srgbClr val="D9622B"/>
-          </a:solidFill>
-          <a:ln/>
-        </p:spPr>
-      </p:sp>
-      <p:sp>
-        <p:nvSpPr>
-          <p:cNvPr id="11" name="Text 9"/>
-          <p:cNvSpPr/>
-          <p:nvPr/>
-        </p:nvSpPr>
-        <p:spPr>
-          <a:xfrm>
-            <a:off x="548640" y="3840480"/>
-            <a:ext cx="457200" cy="457200"/>
-          </a:xfrm>
-          <a:prstGeom prst="rect">
-            <a:avLst/>
-          </a:prstGeom>
-          <a:noFill/>
-          <a:ln/>
-        </p:spPr>
-        <p:txBody>
-          <a:bodyPr wrap="square" lIns="0" tIns="0" rIns="0" bIns="0" rtlCol="0" anchor="ctr"/>
-          <a:lstStyle/>
-          <a:p>
-            <a:pPr algn="ctr" indent="0" marL="0">
-              <a:buNone/>
-            </a:pPr>
-            <a:r>
-              <a:rPr lang="en-US" sz="1300" b="1" dirty="0">
-                <a:solidFill>
-                  <a:srgbClr val="FFFFFF"/>
-                </a:solidFill>
-                <a:latin typeface="Calibri" pitchFamily="34" charset="0"/>
-                <a:ea typeface="Calibri" pitchFamily="34" charset="-122"/>
-                <a:cs typeface="Calibri" pitchFamily="34" charset="-120"/>
-              </a:rPr>
-              <a:t>2</a:t>
-            </a:r>
-            <a:endParaRPr lang="en-US" sz="1300" dirty="0"/>
-          </a:p>
-        </p:txBody>
-      </p:sp>
-      <p:sp>
-        <p:nvSpPr>
-          <p:cNvPr id="12" name="Text 10"/>
-          <p:cNvSpPr/>
-          <p:nvPr/>
-        </p:nvSpPr>
-        <p:spPr>
-          <a:xfrm>
-            <a:off x="1234440" y="3822192"/>
-            <a:ext cx="2926080" cy="502920"/>
+              <a:rPr lang="en-US" sz="950" dirty="0">
+                <a:solidFill>
+                  <a:srgbClr val="3A4553"/>
+                </a:solidFill>
+                <a:latin typeface="Calibri" pitchFamily="34" charset="0"/>
+                <a:ea typeface="Calibri" pitchFamily="34" charset="-122"/>
+                <a:cs typeface="Calibri" pitchFamily="34" charset="-120"/>
+              </a:rPr>
+              <a:t>Of Plant &amp; Machinery's ~₹17.6 Cr original cost has already been depreciated — book value is now ~₹1.8 Cr</a:t>
+            </a:r>
+            <a:endParaRPr lang="en-US" sz="950" dirty="0"/>
+          </a:p>
+        </p:txBody>
+      </p:sp>
+      <p:sp>
+        <p:nvSpPr>
+          <p:cNvPr id="8" name="Text 5"/>
+          <p:cNvSpPr/>
+          <p:nvPr/>
+        </p:nvSpPr>
+        <p:spPr>
+          <a:xfrm>
+            <a:off x="7223760" y="2907792"/>
+            <a:ext cx="4419295" cy="411480"/>
           </a:xfrm>
           <a:prstGeom prst="rect">
             <a:avLst/>
@@ -22121,45 +22519,42 @@
           <a:lstStyle/>
           <a:p>
             <a:pPr indent="0" marL="0">
-              <a:lnSpc>
-                <a:spcPct val="100000"/>
-              </a:lnSpc>
-              <a:buNone/>
-            </a:pPr>
-            <a:r>
-              <a:rPr lang="en-US" sz="1300" b="1" dirty="0">
-                <a:solidFill>
-                  <a:srgbClr val="FFFFFF"/>
-                </a:solidFill>
-                <a:latin typeface="Calibri" pitchFamily="34" charset="0"/>
-                <a:ea typeface="Calibri" pitchFamily="34" charset="-122"/>
-                <a:cs typeface="Calibri" pitchFamily="34" charset="-120"/>
-              </a:rPr>
-              <a:t>Working-capital bridge</a:t>
-            </a:r>
-            <a:endParaRPr lang="en-US" sz="1300" dirty="0"/>
-          </a:p>
-        </p:txBody>
-      </p:sp>
-      <p:sp>
-        <p:nvSpPr>
-          <p:cNvPr id="13" name="Text 11"/>
-          <p:cNvSpPr/>
-          <p:nvPr/>
-        </p:nvSpPr>
-        <p:spPr>
-          <a:xfrm>
-            <a:off x="4297680" y="3794760"/>
-            <a:ext cx="7345375" cy="731520"/>
-          </a:xfrm>
-          <a:prstGeom prst="rect">
-            <a:avLst/>
-          </a:prstGeom>
-          <a:noFill/>
-          <a:ln/>
-        </p:spPr>
-        <p:txBody>
-          <a:bodyPr wrap="square" lIns="0" tIns="0" rIns="0" bIns="0" rtlCol="0" anchor="t"/>
+              <a:buNone/>
+            </a:pPr>
+            <a:r>
+              <a:rPr lang="en-US" sz="2100" b="1" dirty="0">
+                <a:solidFill>
+                  <a:srgbClr val="1C1F26"/>
+                </a:solidFill>
+                <a:latin typeface="Cambria" pitchFamily="34" charset="0"/>
+                <a:ea typeface="Cambria" pitchFamily="34" charset="-122"/>
+                <a:cs typeface="Cambria" pitchFamily="34" charset="-120"/>
+              </a:rPr>
+              <a:t>-₹1.54 Cr</a:t>
+            </a:r>
+            <a:endParaRPr lang="en-US" sz="2100" dirty="0"/>
+          </a:p>
+        </p:txBody>
+      </p:sp>
+      <p:sp>
+        <p:nvSpPr>
+          <p:cNvPr id="9" name="Text 6"/>
+          <p:cNvSpPr/>
+          <p:nvPr/>
+        </p:nvSpPr>
+        <p:spPr>
+          <a:xfrm>
+            <a:off x="7223760" y="3310128"/>
+            <a:ext cx="4419295" cy="685800"/>
+          </a:xfrm>
+          <a:prstGeom prst="rect">
+            <a:avLst/>
+          </a:prstGeom>
+          <a:noFill/>
+          <a:ln/>
+        </p:spPr>
+        <p:txBody>
+          <a:bodyPr wrap="square" lIns="0" tIns="0" rIns="0" bIns="0" rtlCol="0" anchor="ctr"/>
           <a:lstStyle/>
           <a:p>
             <a:pPr indent="0" marL="0">
@@ -22169,89 +22564,30 @@
               <a:buNone/>
             </a:pPr>
             <a:r>
-              <a:rPr lang="en-US" sz="1030" dirty="0">
-                <a:solidFill>
-                  <a:srgbClr val="CBD3DC"/>
-                </a:solidFill>
-                <a:latin typeface="Calibri" pitchFamily="34" charset="0"/>
-                <a:ea typeface="Calibri" pitchFamily="34" charset="-122"/>
-                <a:cs typeface="Calibri" pitchFamily="34" charset="-120"/>
-              </a:rPr>
-              <a:t>Support the Tega/Escorts receivable cycle at the ₹25-30 Cr revenue range Datre has now demonstrated it can reach.</a:t>
-            </a:r>
-            <a:endParaRPr lang="en-US" sz="1030" dirty="0"/>
-          </a:p>
-        </p:txBody>
-      </p:sp>
-      <p:sp>
-        <p:nvSpPr>
-          <p:cNvPr id="14" name="Shape 12"/>
-          <p:cNvSpPr/>
-          <p:nvPr/>
-        </p:nvSpPr>
-        <p:spPr>
-          <a:xfrm>
-            <a:off x="548640" y="4892040"/>
-            <a:ext cx="457200" cy="457200"/>
-          </a:xfrm>
-          <a:prstGeom prst="ellipse">
-            <a:avLst/>
-          </a:prstGeom>
-          <a:solidFill>
-            <a:srgbClr val="D9622B"/>
-          </a:solidFill>
-          <a:ln/>
-        </p:spPr>
-      </p:sp>
-      <p:sp>
-        <p:nvSpPr>
-          <p:cNvPr id="15" name="Text 13"/>
-          <p:cNvSpPr/>
-          <p:nvPr/>
-        </p:nvSpPr>
-        <p:spPr>
-          <a:xfrm>
-            <a:off x="548640" y="4892040"/>
-            <a:ext cx="457200" cy="457200"/>
-          </a:xfrm>
-          <a:prstGeom prst="rect">
-            <a:avLst/>
-          </a:prstGeom>
-          <a:noFill/>
-          <a:ln/>
-        </p:spPr>
-        <p:txBody>
-          <a:bodyPr wrap="square" lIns="0" tIns="0" rIns="0" bIns="0" rtlCol="0" anchor="ctr"/>
-          <a:lstStyle/>
-          <a:p>
-            <a:pPr algn="ctr" indent="0" marL="0">
-              <a:buNone/>
-            </a:pPr>
-            <a:r>
-              <a:rPr lang="en-US" sz="1300" b="1" dirty="0">
-                <a:solidFill>
-                  <a:srgbClr val="FFFFFF"/>
-                </a:solidFill>
-                <a:latin typeface="Calibri" pitchFamily="34" charset="0"/>
-                <a:ea typeface="Calibri" pitchFamily="34" charset="-122"/>
-                <a:cs typeface="Calibri" pitchFamily="34" charset="-120"/>
-              </a:rPr>
-              <a:t>3</a:t>
-            </a:r>
-            <a:endParaRPr lang="en-US" sz="1300" dirty="0"/>
-          </a:p>
-        </p:txBody>
-      </p:sp>
-      <p:sp>
-        <p:nvSpPr>
-          <p:cNvPr id="16" name="Text 14"/>
-          <p:cNvSpPr/>
-          <p:nvPr/>
-        </p:nvSpPr>
-        <p:spPr>
-          <a:xfrm>
-            <a:off x="1234440" y="4873752"/>
-            <a:ext cx="2926080" cy="502920"/>
+              <a:rPr lang="en-US" sz="950" dirty="0">
+                <a:solidFill>
+                  <a:srgbClr val="3A4553"/>
+                </a:solidFill>
+                <a:latin typeface="Calibri" pitchFamily="34" charset="0"/>
+                <a:ea typeface="Calibri" pitchFamily="34" charset="-122"/>
+                <a:cs typeface="Calibri" pitchFamily="34" charset="-120"/>
+              </a:rPr>
+              <a:t>FY25 audited net worth — a literal net-asset-value approach prices the whole enterprise at zero or below</a:t>
+            </a:r>
+            <a:endParaRPr lang="en-US" sz="950" dirty="0"/>
+          </a:p>
+        </p:txBody>
+      </p:sp>
+      <p:sp>
+        <p:nvSpPr>
+          <p:cNvPr id="10" name="Text 7"/>
+          <p:cNvSpPr/>
+          <p:nvPr/>
+        </p:nvSpPr>
+        <p:spPr>
+          <a:xfrm>
+            <a:off x="7223760" y="4078224"/>
+            <a:ext cx="4419295" cy="411480"/>
           </a:xfrm>
           <a:prstGeom prst="rect">
             <a:avLst/>
@@ -22264,45 +22600,42 @@
           <a:lstStyle/>
           <a:p>
             <a:pPr indent="0" marL="0">
-              <a:lnSpc>
-                <a:spcPct val="100000"/>
-              </a:lnSpc>
-              <a:buNone/>
-            </a:pPr>
-            <a:r>
-              <a:rPr lang="en-US" sz="1300" b="1" dirty="0">
-                <a:solidFill>
-                  <a:srgbClr val="FFFFFF"/>
-                </a:solidFill>
-                <a:latin typeface="Calibri" pitchFamily="34" charset="0"/>
-                <a:ea typeface="Calibri" pitchFamily="34" charset="-122"/>
-                <a:cs typeface="Calibri" pitchFamily="34" charset="-120"/>
-              </a:rPr>
-              <a:t>Quality-systems investment</a:t>
-            </a:r>
-            <a:endParaRPr lang="en-US" sz="1300" dirty="0"/>
-          </a:p>
-        </p:txBody>
-      </p:sp>
-      <p:sp>
-        <p:nvSpPr>
-          <p:cNvPr id="17" name="Text 15"/>
-          <p:cNvSpPr/>
-          <p:nvPr/>
-        </p:nvSpPr>
-        <p:spPr>
-          <a:xfrm>
-            <a:off x="4297680" y="4846320"/>
-            <a:ext cx="7345375" cy="731520"/>
-          </a:xfrm>
-          <a:prstGeom prst="rect">
-            <a:avLst/>
-          </a:prstGeom>
-          <a:noFill/>
-          <a:ln/>
-        </p:spPr>
-        <p:txBody>
-          <a:bodyPr wrap="square" lIns="0" tIns="0" rIns="0" bIns="0" rtlCol="0" anchor="t"/>
+              <a:buNone/>
+            </a:pPr>
+            <a:r>
+              <a:rPr lang="en-US" sz="2100" b="1" dirty="0">
+                <a:solidFill>
+                  <a:srgbClr val="1C1F26"/>
+                </a:solidFill>
+                <a:latin typeface="Cambria" pitchFamily="34" charset="0"/>
+                <a:ea typeface="Cambria" pitchFamily="34" charset="-122"/>
+                <a:cs typeface="Cambria" pitchFamily="34" charset="-120"/>
+              </a:rPr>
+              <a:t>3 yrs</a:t>
+            </a:r>
+            <a:endParaRPr lang="en-US" sz="2100" dirty="0"/>
+          </a:p>
+        </p:txBody>
+      </p:sp>
+      <p:sp>
+        <p:nvSpPr>
+          <p:cNvPr id="11" name="Text 8"/>
+          <p:cNvSpPr/>
+          <p:nvPr/>
+        </p:nvSpPr>
+        <p:spPr>
+          <a:xfrm>
+            <a:off x="7223760" y="4480560"/>
+            <a:ext cx="4419295" cy="685800"/>
+          </a:xfrm>
+          <a:prstGeom prst="rect">
+            <a:avLst/>
+          </a:prstGeom>
+          <a:noFill/>
+          <a:ln/>
+        </p:spPr>
+        <p:txBody>
+          <a:bodyPr wrap="square" lIns="0" tIns="0" rIns="0" bIns="0" rtlCol="0" anchor="ctr"/>
           <a:lstStyle/>
           <a:p>
             <a:pPr indent="0" marL="0">
@@ -22312,30 +22645,52 @@
               <a:buNone/>
             </a:pPr>
             <a:r>
-              <a:rPr lang="en-US" sz="1030" dirty="0">
-                <a:solidFill>
-                  <a:srgbClr val="CBD3DC"/>
-                </a:solidFill>
-                <a:latin typeface="Calibri" pitchFamily="34" charset="0"/>
-                <a:ea typeface="Calibri" pitchFamily="34" charset="-122"/>
-                <a:cs typeface="Calibri" pitchFamily="34" charset="-120"/>
-              </a:rPr>
-              <a:t>Targeted spend to bring the rejection rate back toward its FY22-23 low (~2.6%) — scrap-cost savings alone should fund a meaningful share of this.</a:t>
-            </a:r>
-            <a:endParaRPr lang="en-US" sz="1030" dirty="0"/>
-          </a:p>
-        </p:txBody>
-      </p:sp>
-      <p:sp>
-        <p:nvSpPr>
-          <p:cNvPr id="18" name="Text 16"/>
-          <p:cNvSpPr/>
-          <p:nvPr/>
-        </p:nvSpPr>
-        <p:spPr>
-          <a:xfrm>
-            <a:off x="548640" y="5989320"/>
-            <a:ext cx="11094415" cy="457200"/>
+              <a:rPr lang="en-US" sz="950" dirty="0">
+                <a:solidFill>
+                  <a:srgbClr val="3A4553"/>
+                </a:solidFill>
+                <a:latin typeface="Calibri" pitchFamily="34" charset="0"/>
+                <a:ea typeface="Calibri" pitchFamily="34" charset="-122"/>
+                <a:cs typeface="Calibri" pitchFamily="34" charset="-120"/>
+              </a:rPr>
+              <a:t>Straight years of real audited profit (FY23-25) this same balance sheet has been earning</a:t>
+            </a:r>
+            <a:endParaRPr lang="en-US" sz="950" dirty="0"/>
+          </a:p>
+        </p:txBody>
+      </p:sp>
+      <p:sp>
+        <p:nvSpPr>
+          <p:cNvPr id="12" name="Shape 9"/>
+          <p:cNvSpPr/>
+          <p:nvPr/>
+        </p:nvSpPr>
+        <p:spPr>
+          <a:xfrm>
+            <a:off x="548640" y="5669280"/>
+            <a:ext cx="11094415" cy="777240"/>
+          </a:xfrm>
+          <a:prstGeom prst="roundRect">
+            <a:avLst>
+              <a:gd name="adj" fmla="val 9412"/>
+            </a:avLst>
+          </a:prstGeom>
+          <a:solidFill>
+            <a:srgbClr val="FBEEEC"/>
+          </a:solidFill>
+          <a:ln/>
+        </p:spPr>
+      </p:sp>
+      <p:sp>
+        <p:nvSpPr>
+          <p:cNvPr id="13" name="Text 10"/>
+          <p:cNvSpPr/>
+          <p:nvPr/>
+        </p:nvSpPr>
+        <p:spPr>
+          <a:xfrm>
+            <a:off x="777240" y="5669280"/>
+            <a:ext cx="10637215" cy="777240"/>
           </a:xfrm>
           <a:prstGeom prst="rect">
             <a:avLst/>
@@ -22349,20 +22704,20 @@
           <a:p>
             <a:pPr indent="0" marL="0">
               <a:lnSpc>
-                <a:spcPct val="110000"/>
+                <a:spcPct val="112000"/>
               </a:lnSpc>
               <a:buNone/>
             </a:pPr>
             <a:r>
               <a:rPr lang="en-US" sz="950" i="1" dirty="0">
                 <a:solidFill>
-                  <a:srgbClr val="9AA2AD"/>
-                </a:solidFill>
-                <a:latin typeface="Calibri" pitchFamily="34" charset="0"/>
-                <a:ea typeface="Calibri" pitchFamily="34" charset="-122"/>
-                <a:cs typeface="Calibri" pitchFamily="34" charset="-120"/>
-              </a:rPr>
-              <a:t>Any of the three should be sized against audited FY25 and FY25-26 management accounts, not the figures in this deck alone — and against resolution of the governance flags on slide 14.</a:t>
+                  <a:srgbClr val="B8453F"/>
+                </a:solidFill>
+                <a:latin typeface="Calibri" pitchFamily="34" charset="0"/>
+                <a:ea typeface="Calibri" pitchFamily="34" charset="-122"/>
+                <a:cs typeface="Calibri" pitchFamily="34" charset="-120"/>
+              </a:rPr>
+              <a:t>Even the lightest capitalized-earnings estimate (4x PAT ≈ ₹5.7 Cr) is more than 3x the combined book value of every fixed asset on the balance sheet. A pure NAV view can't explain three years of real cash profit — the model, not the business, is the thing that's wrong here.</a:t>
             </a:r>
             <a:endParaRPr lang="en-US" sz="950" dirty="0"/>
           </a:p>
@@ -22370,7 +22725,7 @@
       </p:sp>
       <p:sp>
         <p:nvSpPr>
-          <p:cNvPr id="19" name="Text 17"/>
+          <p:cNvPr id="14" name="Text 11"/>
           <p:cNvSpPr/>
           <p:nvPr/>
         </p:nvSpPr>
@@ -22395,7 +22750,7 @@
             <a:r>
               <a:rPr lang="en-US" sz="800" dirty="0">
                 <a:solidFill>
-                  <a:srgbClr val="8B93A0"/>
+                  <a:srgbClr val="9AA2AD"/>
                 </a:solidFill>
                 <a:latin typeface="Calibri" pitchFamily="34" charset="0"/>
                 <a:ea typeface="Calibri" pitchFamily="34" charset="-122"/>
@@ -22409,7 +22764,7 @@
       </p:sp>
       <p:sp>
         <p:nvSpPr>
-          <p:cNvPr id="20" name="Text 18"/>
+          <p:cNvPr id="15" name="Text 12"/>
           <p:cNvSpPr/>
           <p:nvPr/>
         </p:nvSpPr>
@@ -22434,7 +22789,7 @@
             <a:r>
               <a:rPr lang="en-US" sz="800" dirty="0">
                 <a:solidFill>
-                  <a:srgbClr val="8B93A0"/>
+                  <a:srgbClr val="9AA2AD"/>
                 </a:solidFill>
                 <a:latin typeface="Calibri" pitchFamily="34" charset="0"/>
                 <a:ea typeface="Calibri" pitchFamily="34" charset="-122"/>
@@ -22480,54 +22835,14 @@
       </p:grpSpPr>
       <p:sp>
         <p:nvSpPr>
-          <p:cNvPr id="2" name="Shape 0"/>
-          <p:cNvSpPr/>
-          <p:nvPr/>
-        </p:nvSpPr>
-        <p:spPr>
-          <a:xfrm>
-            <a:off x="9692640" y="-1280160"/>
-            <a:ext cx="4754880" cy="4754880"/>
-          </a:xfrm>
-          <a:prstGeom prst="ellipse">
-            <a:avLst/>
-          </a:prstGeom>
-          <a:solidFill>
-            <a:srgbClr val="262B34"/>
-          </a:solidFill>
-          <a:ln/>
-        </p:spPr>
-      </p:sp>
-      <p:sp>
-        <p:nvSpPr>
-          <p:cNvPr id="3" name="Shape 1"/>
-          <p:cNvSpPr/>
-          <p:nvPr/>
-        </p:nvSpPr>
-        <p:spPr>
-          <a:xfrm>
-            <a:off x="-1463040" y="4572000"/>
-            <a:ext cx="3657600" cy="3657600"/>
-          </a:xfrm>
-          <a:prstGeom prst="ellipse">
-            <a:avLst/>
-          </a:prstGeom>
-          <a:solidFill>
-            <a:srgbClr val="262B34"/>
-          </a:solidFill>
-          <a:ln/>
-        </p:spPr>
-      </p:sp>
-      <p:sp>
-        <p:nvSpPr>
-          <p:cNvPr id="4" name="Text 2"/>
-          <p:cNvSpPr/>
-          <p:nvPr/>
-        </p:nvSpPr>
-        <p:spPr>
-          <a:xfrm>
-            <a:off x="548640" y="2286000"/>
-            <a:ext cx="9144000" cy="731520"/>
+          <p:cNvPr id="2" name="Text 0"/>
+          <p:cNvSpPr/>
+          <p:nvPr/>
+        </p:nvSpPr>
+        <p:spPr>
+          <a:xfrm>
+            <a:off x="548640" y="457200"/>
+            <a:ext cx="4572000" cy="274320"/>
           </a:xfrm>
           <a:prstGeom prst="rect">
             <a:avLst/>
@@ -22543,7 +22858,46 @@
               <a:buNone/>
             </a:pPr>
             <a:r>
-              <a:rPr lang="en-US" sz="3400" b="1" dirty="0">
+              <a:rPr lang="en-US" sz="1100" b="1" spc="200" kern="0" dirty="0">
+                <a:solidFill>
+                  <a:srgbClr val="D9622B"/>
+                </a:solidFill>
+                <a:latin typeface="Calibri" pitchFamily="34" charset="0"/>
+                <a:ea typeface="Calibri" pitchFamily="34" charset="-122"/>
+                <a:cs typeface="Calibri" pitchFamily="34" charset="-120"/>
+              </a:rPr>
+              <a:t>VALUATION — THE BUYER PROBLEM</a:t>
+            </a:r>
+            <a:endParaRPr lang="en-US" sz="1100" dirty="0"/>
+          </a:p>
+        </p:txBody>
+      </p:sp>
+      <p:sp>
+        <p:nvSpPr>
+          <p:cNvPr id="3" name="Text 1"/>
+          <p:cNvSpPr/>
+          <p:nvPr/>
+        </p:nvSpPr>
+        <p:spPr>
+          <a:xfrm>
+            <a:off x="548640" y="841248"/>
+            <a:ext cx="11094415" cy="685800"/>
+          </a:xfrm>
+          <a:prstGeom prst="rect">
+            <a:avLst/>
+          </a:prstGeom>
+          <a:noFill/>
+          <a:ln/>
+        </p:spPr>
+        <p:txBody>
+          <a:bodyPr wrap="square" lIns="0" tIns="0" rIns="0" bIns="0" rtlCol="0" anchor="ctr"/>
+          <a:lstStyle/>
+          <a:p>
+            <a:pPr algn="l" indent="0" marL="0">
+              <a:buNone/>
+            </a:pPr>
+            <a:r>
+              <a:rPr lang="en-US" sz="3000" b="1" dirty="0">
                 <a:solidFill>
                   <a:srgbClr val="FFFFFF"/>
                 </a:solidFill>
@@ -22551,11 +22905,31 @@
                 <a:ea typeface="Cambria" pitchFamily="34" charset="-122"/>
                 <a:cs typeface="Cambria" pitchFamily="34" charset="-120"/>
               </a:rPr>
-              <a:t>Datre Corporation Limited</a:t>
-            </a:r>
-            <a:endParaRPr lang="en-US" sz="3400" dirty="0"/>
-          </a:p>
-        </p:txBody>
+              <a:t>Why it's still hard to sell — and why that isn't a flaw</a:t>
+            </a:r>
+            <a:endParaRPr lang="en-US" sz="3000" dirty="0"/>
+          </a:p>
+        </p:txBody>
+      </p:sp>
+      <p:sp>
+        <p:nvSpPr>
+          <p:cNvPr id="4" name="Shape 2"/>
+          <p:cNvSpPr/>
+          <p:nvPr/>
+        </p:nvSpPr>
+        <p:spPr>
+          <a:xfrm>
+            <a:off x="548640" y="1737360"/>
+            <a:ext cx="384048" cy="384048"/>
+          </a:xfrm>
+          <a:prstGeom prst="ellipse">
+            <a:avLst/>
+          </a:prstGeom>
+          <a:solidFill>
+            <a:srgbClr val="D9622B"/>
+          </a:solidFill>
+          <a:ln/>
+        </p:spPr>
       </p:sp>
       <p:sp>
         <p:nvSpPr>
@@ -22565,8 +22939,47 @@
         </p:nvSpPr>
         <p:spPr>
           <a:xfrm>
-            <a:off x="548640" y="2971800"/>
-            <a:ext cx="9144000" cy="457200"/>
+            <a:off x="548640" y="1737360"/>
+            <a:ext cx="384048" cy="384048"/>
+          </a:xfrm>
+          <a:prstGeom prst="rect">
+            <a:avLst/>
+          </a:prstGeom>
+          <a:noFill/>
+          <a:ln/>
+        </p:spPr>
+        <p:txBody>
+          <a:bodyPr wrap="square" lIns="0" tIns="0" rIns="0" bIns="0" rtlCol="0" anchor="ctr"/>
+          <a:lstStyle/>
+          <a:p>
+            <a:pPr algn="ctr" indent="0" marL="0">
+              <a:buNone/>
+            </a:pPr>
+            <a:r>
+              <a:rPr lang="en-US" sz="1092" b="1" dirty="0">
+                <a:solidFill>
+                  <a:srgbClr val="FFFFFF"/>
+                </a:solidFill>
+                <a:latin typeface="Calibri" pitchFamily="34" charset="0"/>
+                <a:ea typeface="Calibri" pitchFamily="34" charset="-122"/>
+                <a:cs typeface="Calibri" pitchFamily="34" charset="-120"/>
+              </a:rPr>
+              <a:t>1</a:t>
+            </a:r>
+            <a:endParaRPr lang="en-US" sz="1092" dirty="0"/>
+          </a:p>
+        </p:txBody>
+      </p:sp>
+      <p:sp>
+        <p:nvSpPr>
+          <p:cNvPr id="6" name="Text 4"/>
+          <p:cNvSpPr/>
+          <p:nvPr/>
+        </p:nvSpPr>
+        <p:spPr>
+          <a:xfrm>
+            <a:off x="1115568" y="1709928"/>
+            <a:ext cx="10527487" cy="365760"/>
           </a:xfrm>
           <a:prstGeom prst="rect">
             <a:avLst/>
@@ -22582,56 +22995,17 @@
               <a:buNone/>
             </a:pPr>
             <a:r>
-              <a:rPr lang="en-US" sz="1500" i="1" dirty="0">
-                <a:solidFill>
-                  <a:srgbClr val="CBD3DC"/>
-                </a:solidFill>
-                <a:latin typeface="Calibri" pitchFamily="34" charset="0"/>
-                <a:ea typeface="Calibri" pitchFamily="34" charset="-122"/>
-                <a:cs typeface="Calibri" pitchFamily="34" charset="-120"/>
-              </a:rPr>
-              <a:t>Engineering Essence, Manufacturing Personified</a:t>
-            </a:r>
-            <a:endParaRPr lang="en-US" sz="1500" dirty="0"/>
-          </a:p>
-        </p:txBody>
-      </p:sp>
-      <p:sp>
-        <p:nvSpPr>
-          <p:cNvPr id="6" name="Text 4"/>
-          <p:cNvSpPr/>
-          <p:nvPr/>
-        </p:nvSpPr>
-        <p:spPr>
-          <a:xfrm>
-            <a:off x="548640" y="4023360"/>
-            <a:ext cx="2743200" cy="274320"/>
-          </a:xfrm>
-          <a:prstGeom prst="rect">
-            <a:avLst/>
-          </a:prstGeom>
-          <a:noFill/>
-          <a:ln/>
-        </p:spPr>
-        <p:txBody>
-          <a:bodyPr wrap="square" lIns="0" tIns="0" rIns="0" bIns="0" rtlCol="0" anchor="ctr"/>
-          <a:lstStyle/>
-          <a:p>
-            <a:pPr indent="0" marL="0">
-              <a:buNone/>
-            </a:pPr>
-            <a:r>
-              <a:rPr lang="en-US" sz="950" b="1" spc="100" kern="0" dirty="0">
-                <a:solidFill>
-                  <a:srgbClr val="D9622B"/>
-                </a:solidFill>
-                <a:latin typeface="Calibri" pitchFamily="34" charset="0"/>
-                <a:ea typeface="Calibri" pitchFamily="34" charset="-122"/>
-                <a:cs typeface="Calibri" pitchFamily="34" charset="-120"/>
-              </a:rPr>
-              <a:t>REGISTERED OFFICE</a:t>
-            </a:r>
-            <a:endParaRPr lang="en-US" sz="950" dirty="0"/>
+              <a:rPr lang="en-US" sz="1350" b="1" dirty="0">
+                <a:solidFill>
+                  <a:srgbClr val="FFFFFF"/>
+                </a:solidFill>
+                <a:latin typeface="Calibri" pitchFamily="34" charset="0"/>
+                <a:ea typeface="Calibri" pitchFamily="34" charset="-122"/>
+                <a:cs typeface="Calibri" pitchFamily="34" charset="-120"/>
+              </a:rPr>
+              <a:t>Liquidation value: a generic buyer's logic</a:t>
+            </a:r>
+            <a:endParaRPr lang="en-US" sz="1350" dirty="0"/>
           </a:p>
         </p:txBody>
       </p:sp>
@@ -22643,203 +23017,8 @@
         </p:nvSpPr>
         <p:spPr>
           <a:xfrm>
-            <a:off x="548640" y="4279392"/>
-            <a:ext cx="9144000" cy="365760"/>
-          </a:xfrm>
-          <a:prstGeom prst="rect">
-            <a:avLst/>
-          </a:prstGeom>
-          <a:noFill/>
-          <a:ln/>
-        </p:spPr>
-        <p:txBody>
-          <a:bodyPr wrap="square" lIns="0" tIns="0" rIns="0" bIns="0" rtlCol="0" anchor="ctr"/>
-          <a:lstStyle/>
-          <a:p>
-            <a:pPr indent="0" marL="0">
-              <a:buNone/>
-            </a:pPr>
-            <a:r>
-              <a:rPr lang="en-US" sz="1200" dirty="0">
-                <a:solidFill>
-                  <a:srgbClr val="FFFFFF"/>
-                </a:solidFill>
-                <a:latin typeface="Calibri" pitchFamily="34" charset="0"/>
-                <a:ea typeface="Calibri" pitchFamily="34" charset="-122"/>
-                <a:cs typeface="Calibri" pitchFamily="34" charset="-120"/>
-              </a:rPr>
-              <a:t>Sector-III, Falta Industrial Growth Centre, South 24 Parganas, West Bengal 743504, India</a:t>
-            </a:r>
-            <a:endParaRPr lang="en-US" sz="1200" dirty="0"/>
-          </a:p>
-        </p:txBody>
-      </p:sp>
-      <p:sp>
-        <p:nvSpPr>
-          <p:cNvPr id="8" name="Text 6"/>
-          <p:cNvSpPr/>
-          <p:nvPr/>
-        </p:nvSpPr>
-        <p:spPr>
-          <a:xfrm>
-            <a:off x="548640" y="4681728"/>
-            <a:ext cx="2743200" cy="274320"/>
-          </a:xfrm>
-          <a:prstGeom prst="rect">
-            <a:avLst/>
-          </a:prstGeom>
-          <a:noFill/>
-          <a:ln/>
-        </p:spPr>
-        <p:txBody>
-          <a:bodyPr wrap="square" lIns="0" tIns="0" rIns="0" bIns="0" rtlCol="0" anchor="ctr"/>
-          <a:lstStyle/>
-          <a:p>
-            <a:pPr indent="0" marL="0">
-              <a:buNone/>
-            </a:pPr>
-            <a:r>
-              <a:rPr lang="en-US" sz="950" b="1" spc="100" kern="0" dirty="0">
-                <a:solidFill>
-                  <a:srgbClr val="D9622B"/>
-                </a:solidFill>
-                <a:latin typeface="Calibri" pitchFamily="34" charset="0"/>
-                <a:ea typeface="Calibri" pitchFamily="34" charset="-122"/>
-                <a:cs typeface="Calibri" pitchFamily="34" charset="-120"/>
-              </a:rPr>
-              <a:t>CONTACT</a:t>
-            </a:r>
-            <a:endParaRPr lang="en-US" sz="950" dirty="0"/>
-          </a:p>
-        </p:txBody>
-      </p:sp>
-      <p:sp>
-        <p:nvSpPr>
-          <p:cNvPr id="9" name="Text 7"/>
-          <p:cNvSpPr/>
-          <p:nvPr/>
-        </p:nvSpPr>
-        <p:spPr>
-          <a:xfrm>
-            <a:off x="548640" y="4937760"/>
-            <a:ext cx="9144000" cy="365760"/>
-          </a:xfrm>
-          <a:prstGeom prst="rect">
-            <a:avLst/>
-          </a:prstGeom>
-          <a:noFill/>
-          <a:ln/>
-        </p:spPr>
-        <p:txBody>
-          <a:bodyPr wrap="square" lIns="0" tIns="0" rIns="0" bIns="0" rtlCol="0" anchor="ctr"/>
-          <a:lstStyle/>
-          <a:p>
-            <a:pPr indent="0" marL="0">
-              <a:buNone/>
-            </a:pPr>
-            <a:r>
-              <a:rPr lang="en-US" sz="1200" dirty="0">
-                <a:solidFill>
-                  <a:srgbClr val="FFFFFF"/>
-                </a:solidFill>
-                <a:latin typeface="Calibri" pitchFamily="34" charset="0"/>
-                <a:ea typeface="Calibri" pitchFamily="34" charset="-122"/>
-                <a:cs typeface="Calibri" pitchFamily="34" charset="-120"/>
-              </a:rPr>
-              <a:t>sales@datre.com  ·  hr@datre.com  ·  www.datre.in</a:t>
-            </a:r>
-            <a:endParaRPr lang="en-US" sz="1200" dirty="0"/>
-          </a:p>
-        </p:txBody>
-      </p:sp>
-      <p:sp>
-        <p:nvSpPr>
-          <p:cNvPr id="10" name="Text 8"/>
-          <p:cNvSpPr/>
-          <p:nvPr/>
-        </p:nvSpPr>
-        <p:spPr>
-          <a:xfrm>
-            <a:off x="548640" y="5340096"/>
-            <a:ext cx="2743200" cy="274320"/>
-          </a:xfrm>
-          <a:prstGeom prst="rect">
-            <a:avLst/>
-          </a:prstGeom>
-          <a:noFill/>
-          <a:ln/>
-        </p:spPr>
-        <p:txBody>
-          <a:bodyPr wrap="square" lIns="0" tIns="0" rIns="0" bIns="0" rtlCol="0" anchor="ctr"/>
-          <a:lstStyle/>
-          <a:p>
-            <a:pPr indent="0" marL="0">
-              <a:buNone/>
-            </a:pPr>
-            <a:r>
-              <a:rPr lang="en-US" sz="950" b="1" spc="100" kern="0" dirty="0">
-                <a:solidFill>
-                  <a:srgbClr val="D9622B"/>
-                </a:solidFill>
-                <a:latin typeface="Calibri" pitchFamily="34" charset="0"/>
-                <a:ea typeface="Calibri" pitchFamily="34" charset="-122"/>
-                <a:cs typeface="Calibri" pitchFamily="34" charset="-120"/>
-              </a:rPr>
-              <a:t>PREPARED FOR</a:t>
-            </a:r>
-            <a:endParaRPr lang="en-US" sz="950" dirty="0"/>
-          </a:p>
-        </p:txBody>
-      </p:sp>
-      <p:sp>
-        <p:nvSpPr>
-          <p:cNvPr id="11" name="Text 9"/>
-          <p:cNvSpPr/>
-          <p:nvPr/>
-        </p:nvSpPr>
-        <p:spPr>
-          <a:xfrm>
-            <a:off x="548640" y="5596128"/>
-            <a:ext cx="9144000" cy="365760"/>
-          </a:xfrm>
-          <a:prstGeom prst="rect">
-            <a:avLst/>
-          </a:prstGeom>
-          <a:noFill/>
-          <a:ln/>
-        </p:spPr>
-        <p:txBody>
-          <a:bodyPr wrap="square" lIns="0" tIns="0" rIns="0" bIns="0" rtlCol="0" anchor="ctr"/>
-          <a:lstStyle/>
-          <a:p>
-            <a:pPr indent="0" marL="0">
-              <a:buNone/>
-            </a:pPr>
-            <a:r>
-              <a:rPr lang="en-US" sz="1200" dirty="0">
-                <a:solidFill>
-                  <a:srgbClr val="FFFFFF"/>
-                </a:solidFill>
-                <a:latin typeface="Calibri" pitchFamily="34" charset="0"/>
-                <a:ea typeface="Calibri" pitchFamily="34" charset="-122"/>
-                <a:cs typeface="Calibri" pitchFamily="34" charset="-120"/>
-              </a:rPr>
-              <a:t>Investor discussion — Indranil Dutta, Chief Executive Officer</a:t>
-            </a:r>
-            <a:endParaRPr lang="en-US" sz="1200" dirty="0"/>
-          </a:p>
-        </p:txBody>
-      </p:sp>
-      <p:sp>
-        <p:nvSpPr>
-          <p:cNvPr id="12" name="Text 10"/>
-          <p:cNvSpPr/>
-          <p:nvPr/>
-        </p:nvSpPr>
-        <p:spPr>
-          <a:xfrm>
-            <a:off x="548640" y="5943600"/>
-            <a:ext cx="11094415" cy="640080"/>
+            <a:off x="1115568" y="2084832"/>
+            <a:ext cx="10527487" cy="658368"/>
           </a:xfrm>
           <a:prstGeom prst="rect">
             <a:avLst/>
@@ -22858,15 +23037,440 @@
               <a:buNone/>
             </a:pPr>
             <a:r>
+              <a:rPr lang="en-US" sz="1000" dirty="0">
+                <a:solidFill>
+                  <a:srgbClr val="CBD3DC"/>
+                </a:solidFill>
+                <a:latin typeface="Calibri" pitchFamily="34" charset="0"/>
+                <a:ea typeface="Calibri" pitchFamily="34" charset="-122"/>
+                <a:cs typeface="Calibri" pitchFamily="34" charset="-120"/>
+              </a:rPr>
+              <a:t>A machinery dealer or plot buyer can only underwrite what they can verify and reuse immediately — the hardware. They have no way to price 25-30 years of heat-treatment process history, RDSO/OEM qualifications, or a customer book earned through years of trial batches and audits.</a:t>
+            </a:r>
+            <a:endParaRPr lang="en-US" sz="1000" dirty="0"/>
+          </a:p>
+        </p:txBody>
+      </p:sp>
+      <p:sp>
+        <p:nvSpPr>
+          <p:cNvPr id="8" name="Shape 6"/>
+          <p:cNvSpPr/>
+          <p:nvPr/>
+        </p:nvSpPr>
+        <p:spPr>
+          <a:xfrm>
+            <a:off x="548640" y="2834640"/>
+            <a:ext cx="384048" cy="384048"/>
+          </a:xfrm>
+          <a:prstGeom prst="ellipse">
+            <a:avLst/>
+          </a:prstGeom>
+          <a:solidFill>
+            <a:srgbClr val="D9622B"/>
+          </a:solidFill>
+          <a:ln/>
+        </p:spPr>
+      </p:sp>
+      <p:sp>
+        <p:nvSpPr>
+          <p:cNvPr id="9" name="Text 7"/>
+          <p:cNvSpPr/>
+          <p:nvPr/>
+        </p:nvSpPr>
+        <p:spPr>
+          <a:xfrm>
+            <a:off x="548640" y="2834640"/>
+            <a:ext cx="384048" cy="384048"/>
+          </a:xfrm>
+          <a:prstGeom prst="rect">
+            <a:avLst/>
+          </a:prstGeom>
+          <a:noFill/>
+          <a:ln/>
+        </p:spPr>
+        <p:txBody>
+          <a:bodyPr wrap="square" lIns="0" tIns="0" rIns="0" bIns="0" rtlCol="0" anchor="ctr"/>
+          <a:lstStyle/>
+          <a:p>
+            <a:pPr algn="ctr" indent="0" marL="0">
+              <a:buNone/>
+            </a:pPr>
+            <a:r>
+              <a:rPr lang="en-US" sz="1092" b="1" dirty="0">
+                <a:solidFill>
+                  <a:srgbClr val="FFFFFF"/>
+                </a:solidFill>
+                <a:latin typeface="Calibri" pitchFamily="34" charset="0"/>
+                <a:ea typeface="Calibri" pitchFamily="34" charset="-122"/>
+                <a:cs typeface="Calibri" pitchFamily="34" charset="-120"/>
+              </a:rPr>
+              <a:t>2</a:t>
+            </a:r>
+            <a:endParaRPr lang="en-US" sz="1092" dirty="0"/>
+          </a:p>
+        </p:txBody>
+      </p:sp>
+      <p:sp>
+        <p:nvSpPr>
+          <p:cNvPr id="10" name="Text 8"/>
+          <p:cNvSpPr/>
+          <p:nvPr/>
+        </p:nvSpPr>
+        <p:spPr>
+          <a:xfrm>
+            <a:off x="1115568" y="2807208"/>
+            <a:ext cx="10527487" cy="365760"/>
+          </a:xfrm>
+          <a:prstGeom prst="rect">
+            <a:avLst/>
+          </a:prstGeom>
+          <a:noFill/>
+          <a:ln/>
+        </p:spPr>
+        <p:txBody>
+          <a:bodyPr wrap="square" lIns="0" tIns="0" rIns="0" bIns="0" rtlCol="0" anchor="ctr"/>
+          <a:lstStyle/>
+          <a:p>
+            <a:pPr indent="0" marL="0">
+              <a:buNone/>
+            </a:pPr>
+            <a:r>
+              <a:rPr lang="en-US" sz="1350" b="1" dirty="0">
+                <a:solidFill>
+                  <a:srgbClr val="FFFFFF"/>
+                </a:solidFill>
+                <a:latin typeface="Calibri" pitchFamily="34" charset="0"/>
+                <a:ea typeface="Calibri" pitchFamily="34" charset="-122"/>
+                <a:cs typeface="Calibri" pitchFamily="34" charset="-120"/>
+              </a:rPr>
+              <a:t>Fair market value: what the business earns standalone</a:t>
+            </a:r>
+            <a:endParaRPr lang="en-US" sz="1350" dirty="0"/>
+          </a:p>
+        </p:txBody>
+      </p:sp>
+      <p:sp>
+        <p:nvSpPr>
+          <p:cNvPr id="11" name="Text 9"/>
+          <p:cNvSpPr/>
+          <p:nvPr/>
+        </p:nvSpPr>
+        <p:spPr>
+          <a:xfrm>
+            <a:off x="1115568" y="3182112"/>
+            <a:ext cx="10527487" cy="658368"/>
+          </a:xfrm>
+          <a:prstGeom prst="rect">
+            <a:avLst/>
+          </a:prstGeom>
+          <a:noFill/>
+          <a:ln/>
+        </p:spPr>
+        <p:txBody>
+          <a:bodyPr wrap="square" lIns="0" tIns="0" rIns="0" bIns="0" rtlCol="0" anchor="ctr"/>
+          <a:lstStyle/>
+          <a:p>
+            <a:pPr indent="0" marL="0">
+              <a:lnSpc>
+                <a:spcPct val="115000"/>
+              </a:lnSpc>
+              <a:buNone/>
+            </a:pPr>
+            <a:r>
+              <a:rPr lang="en-US" sz="1000" dirty="0">
+                <a:solidFill>
+                  <a:srgbClr val="CBD3DC"/>
+                </a:solidFill>
+                <a:latin typeface="Calibri" pitchFamily="34" charset="0"/>
+                <a:ea typeface="Calibri" pitchFamily="34" charset="-122"/>
+                <a:cs typeface="Calibri" pitchFamily="34" charset="-120"/>
+              </a:rPr>
+              <a:t>Even on light, illustrative multiples, capitalized earnings already clear 3x+ the entire fixed-asset book (slide 25). This is the value a rational financial buyer, with no synergy, would underwrite.</a:t>
+            </a:r>
+            <a:endParaRPr lang="en-US" sz="1000" dirty="0"/>
+          </a:p>
+        </p:txBody>
+      </p:sp>
+      <p:sp>
+        <p:nvSpPr>
+          <p:cNvPr id="12" name="Shape 10"/>
+          <p:cNvSpPr/>
+          <p:nvPr/>
+        </p:nvSpPr>
+        <p:spPr>
+          <a:xfrm>
+            <a:off x="548640" y="3931920"/>
+            <a:ext cx="384048" cy="384048"/>
+          </a:xfrm>
+          <a:prstGeom prst="ellipse">
+            <a:avLst/>
+          </a:prstGeom>
+          <a:solidFill>
+            <a:srgbClr val="D9622B"/>
+          </a:solidFill>
+          <a:ln/>
+        </p:spPr>
+      </p:sp>
+      <p:sp>
+        <p:nvSpPr>
+          <p:cNvPr id="13" name="Text 11"/>
+          <p:cNvSpPr/>
+          <p:nvPr/>
+        </p:nvSpPr>
+        <p:spPr>
+          <a:xfrm>
+            <a:off x="548640" y="3931920"/>
+            <a:ext cx="384048" cy="384048"/>
+          </a:xfrm>
+          <a:prstGeom prst="rect">
+            <a:avLst/>
+          </a:prstGeom>
+          <a:noFill/>
+          <a:ln/>
+        </p:spPr>
+        <p:txBody>
+          <a:bodyPr wrap="square" lIns="0" tIns="0" rIns="0" bIns="0" rtlCol="0" anchor="ctr"/>
+          <a:lstStyle/>
+          <a:p>
+            <a:pPr algn="ctr" indent="0" marL="0">
+              <a:buNone/>
+            </a:pPr>
+            <a:r>
+              <a:rPr lang="en-US" sz="1092" b="1" dirty="0">
+                <a:solidFill>
+                  <a:srgbClr val="FFFFFF"/>
+                </a:solidFill>
+                <a:latin typeface="Calibri" pitchFamily="34" charset="0"/>
+                <a:ea typeface="Calibri" pitchFamily="34" charset="-122"/>
+                <a:cs typeface="Calibri" pitchFamily="34" charset="-120"/>
+              </a:rPr>
+              <a:t>3</a:t>
+            </a:r>
+            <a:endParaRPr lang="en-US" sz="1092" dirty="0"/>
+          </a:p>
+        </p:txBody>
+      </p:sp>
+      <p:sp>
+        <p:nvSpPr>
+          <p:cNvPr id="14" name="Text 12"/>
+          <p:cNvSpPr/>
+          <p:nvPr/>
+        </p:nvSpPr>
+        <p:spPr>
+          <a:xfrm>
+            <a:off x="1115568" y="3904488"/>
+            <a:ext cx="10527487" cy="365760"/>
+          </a:xfrm>
+          <a:prstGeom prst="rect">
+            <a:avLst/>
+          </a:prstGeom>
+          <a:noFill/>
+          <a:ln/>
+        </p:spPr>
+        <p:txBody>
+          <a:bodyPr wrap="square" lIns="0" tIns="0" rIns="0" bIns="0" rtlCol="0" anchor="ctr"/>
+          <a:lstStyle/>
+          <a:p>
+            <a:pPr indent="0" marL="0">
+              <a:buNone/>
+            </a:pPr>
+            <a:r>
+              <a:rPr lang="en-US" sz="1350" b="1" dirty="0">
+                <a:solidFill>
+                  <a:srgbClr val="FFFFFF"/>
+                </a:solidFill>
+                <a:latin typeface="Calibri" pitchFamily="34" charset="0"/>
+                <a:ea typeface="Calibri" pitchFamily="34" charset="-122"/>
+                <a:cs typeface="Calibri" pitchFamily="34" charset="-120"/>
+              </a:rPr>
+              <a:t>Strategic value: what it's worth to the right buyer</a:t>
+            </a:r>
+            <a:endParaRPr lang="en-US" sz="1350" dirty="0"/>
+          </a:p>
+        </p:txBody>
+      </p:sp>
+      <p:sp>
+        <p:nvSpPr>
+          <p:cNvPr id="15" name="Text 13"/>
+          <p:cNvSpPr/>
+          <p:nvPr/>
+        </p:nvSpPr>
+        <p:spPr>
+          <a:xfrm>
+            <a:off x="1115568" y="4279392"/>
+            <a:ext cx="10527487" cy="658368"/>
+          </a:xfrm>
+          <a:prstGeom prst="rect">
+            <a:avLst/>
+          </a:prstGeom>
+          <a:noFill/>
+          <a:ln/>
+        </p:spPr>
+        <p:txBody>
+          <a:bodyPr wrap="square" lIns="0" tIns="0" rIns="0" bIns="0" rtlCol="0" anchor="ctr"/>
+          <a:lstStyle/>
+          <a:p>
+            <a:pPr indent="0" marL="0">
+              <a:lnSpc>
+                <a:spcPct val="115000"/>
+              </a:lnSpc>
+              <a:buNone/>
+            </a:pPr>
+            <a:r>
+              <a:rPr lang="en-US" sz="1000" dirty="0">
+                <a:solidFill>
+                  <a:srgbClr val="CBD3DC"/>
+                </a:solidFill>
+                <a:latin typeface="Calibri" pitchFamily="34" charset="0"/>
+                <a:ea typeface="Calibri" pitchFamily="34" charset="-122"/>
+                <a:cs typeface="Calibri" pitchFamily="34" charset="-120"/>
+              </a:rPr>
+              <a:t>An OEM wanting captive supply, or a foundry group wanting instant access to Datre's Tier-1 relationships, avoids the same multi-year, uncertain-utilization qualification cost any new entrant faces. That's the ceiling few generic buyers can pay — and only a narrow buyer set can underwrite it.</a:t>
+            </a:r>
+            <a:endParaRPr lang="en-US" sz="1000" dirty="0"/>
+          </a:p>
+        </p:txBody>
+      </p:sp>
+      <p:sp>
+        <p:nvSpPr>
+          <p:cNvPr id="16" name="Shape 14"/>
+          <p:cNvSpPr/>
+          <p:nvPr/>
+        </p:nvSpPr>
+        <p:spPr>
+          <a:xfrm>
+            <a:off x="548640" y="5029200"/>
+            <a:ext cx="11094415" cy="1005840"/>
+          </a:xfrm>
+          <a:prstGeom prst="roundRect">
+            <a:avLst>
+              <a:gd name="adj" fmla="val 7273"/>
+            </a:avLst>
+          </a:prstGeom>
+          <a:solidFill>
+            <a:srgbClr val="262B34"/>
+          </a:solidFill>
+          <a:ln/>
+        </p:spPr>
+      </p:sp>
+      <p:sp>
+        <p:nvSpPr>
+          <p:cNvPr id="17" name="Text 15"/>
+          <p:cNvSpPr/>
+          <p:nvPr/>
+        </p:nvSpPr>
+        <p:spPr>
+          <a:xfrm>
+            <a:off x="822960" y="5166360"/>
+            <a:ext cx="10545775" cy="274320"/>
+          </a:xfrm>
+          <a:prstGeom prst="rect">
+            <a:avLst/>
+          </a:prstGeom>
+          <a:noFill/>
+          <a:ln/>
+        </p:spPr>
+        <p:txBody>
+          <a:bodyPr wrap="square" lIns="0" tIns="0" rIns="0" bIns="0" rtlCol="0" anchor="ctr"/>
+          <a:lstStyle/>
+          <a:p>
+            <a:pPr indent="0" marL="0">
+              <a:buNone/>
+            </a:pPr>
+            <a:r>
+              <a:rPr lang="en-US" sz="1000" b="1" spc="100" kern="0" dirty="0">
+                <a:solidFill>
+                  <a:srgbClr val="E8B84B"/>
+                </a:solidFill>
+                <a:latin typeface="Calibri" pitchFamily="34" charset="0"/>
+                <a:ea typeface="Calibri" pitchFamily="34" charset="-122"/>
+                <a:cs typeface="Calibri" pitchFamily="34" charset="-120"/>
+              </a:rPr>
+              <a:t>RECOMMENDATION</a:t>
+            </a:r>
+            <a:endParaRPr lang="en-US" sz="1000" dirty="0"/>
+          </a:p>
+        </p:txBody>
+      </p:sp>
+      <p:sp>
+        <p:nvSpPr>
+          <p:cNvPr id="18" name="Text 16"/>
+          <p:cNvSpPr/>
+          <p:nvPr/>
+        </p:nvSpPr>
+        <p:spPr>
+          <a:xfrm>
+            <a:off x="822960" y="5440680"/>
+            <a:ext cx="10545775" cy="548640"/>
+          </a:xfrm>
+          <a:prstGeom prst="rect">
+            <a:avLst/>
+          </a:prstGeom>
+          <a:noFill/>
+          <a:ln/>
+        </p:spPr>
+        <p:txBody>
+          <a:bodyPr wrap="square" lIns="0" tIns="0" rIns="0" bIns="0" rtlCol="0" anchor="ctr"/>
+          <a:lstStyle/>
+          <a:p>
+            <a:pPr indent="0" marL="0">
+              <a:lnSpc>
+                <a:spcPct val="110000"/>
+              </a:lnSpc>
+              <a:buNone/>
+            </a:pPr>
+            <a:r>
+              <a:rPr lang="en-US" sz="1000" dirty="0">
+                <a:solidFill>
+                  <a:srgbClr val="FFFFFF"/>
+                </a:solidFill>
+                <a:latin typeface="Calibri" pitchFamily="34" charset="0"/>
+                <a:ea typeface="Calibri" pitchFamily="34" charset="-122"/>
+                <a:cs typeface="Calibri" pitchFamily="34" charset="-120"/>
+              </a:rPr>
+              <a:t>Negotiate on earnings capacity plus a named strategic premium, not on net-asset value of 30-year-old machinery. A thin pool of qualified buyers is a sale-process problem, solved with a targeted and patient process — not a reason to discount enterprise value to book.</a:t>
+            </a:r>
+            <a:endParaRPr lang="en-US" sz="1000" dirty="0"/>
+          </a:p>
+        </p:txBody>
+      </p:sp>
+      <p:sp>
+        <p:nvSpPr>
+          <p:cNvPr id="19" name="Text 17"/>
+          <p:cNvSpPr/>
+          <p:nvPr/>
+        </p:nvSpPr>
+        <p:spPr>
+          <a:xfrm>
+            <a:off x="548640" y="6144768"/>
+            <a:ext cx="11094415" cy="320040"/>
+          </a:xfrm>
+          <a:prstGeom prst="rect">
+            <a:avLst/>
+          </a:prstGeom>
+          <a:noFill/>
+          <a:ln/>
+        </p:spPr>
+        <p:txBody>
+          <a:bodyPr wrap="square" lIns="0" tIns="0" rIns="0" bIns="0" rtlCol="0" anchor="ctr"/>
+          <a:lstStyle/>
+          <a:p>
+            <a:pPr indent="0" marL="0">
+              <a:lnSpc>
+                <a:spcPct val="110000"/>
+              </a:lnSpc>
+              <a:buNone/>
+            </a:pPr>
+            <a:r>
               <a:rPr lang="en-US" sz="850" i="1" dirty="0">
                 <a:solidFill>
-                  <a:srgbClr val="7A828E"/>
-                </a:solidFill>
-                <a:latin typeface="Calibri" pitchFamily="34" charset="0"/>
-                <a:ea typeface="Calibri" pitchFamily="34" charset="-122"/>
-                <a:cs typeface="Calibri" pitchFamily="34" charset="-120"/>
-              </a:rPr>
-              <a:t>This document consolidates the company's own financial statements, management information system reports and internal analyses. Figures are sourced and dated throughout; where audited and unaudited data diverge, both are shown. Confidential — prepared for internal investor discussion only.</a:t>
+                  <a:srgbClr val="9AA2AD"/>
+                </a:solidFill>
+                <a:latin typeface="Calibri" pitchFamily="34" charset="0"/>
+                <a:ea typeface="Calibri" pitchFamily="34" charset="-122"/>
+                <a:cs typeface="Calibri" pitchFamily="34" charset="-120"/>
+              </a:rPr>
+              <a:t>This framework uses Datre's own audited and internal records for the asset and earnings figures; the FMV multiples and the existence/identity of a strategic buyer are illustrative and unverified. Recommend a formal valuation (registered valuer / IBBI standards) before using this for negotiation.</a:t>
             </a:r>
             <a:endParaRPr lang="en-US" sz="850" dirty="0"/>
           </a:p>
@@ -22874,7 +23478,46 @@
       </p:sp>
       <p:sp>
         <p:nvSpPr>
-          <p:cNvPr id="13" name="Text 11"/>
+          <p:cNvPr id="20" name="Text 18"/>
+          <p:cNvSpPr/>
+          <p:nvPr/>
+        </p:nvSpPr>
+        <p:spPr>
+          <a:xfrm>
+            <a:off x="548640" y="6473952"/>
+            <a:ext cx="11094415" cy="274320"/>
+          </a:xfrm>
+          <a:prstGeom prst="rect">
+            <a:avLst/>
+          </a:prstGeom>
+          <a:noFill/>
+          <a:ln/>
+        </p:spPr>
+        <p:txBody>
+          <a:bodyPr wrap="square" lIns="0" tIns="0" rIns="0" bIns="0" rtlCol="0" anchor="ctr"/>
+          <a:lstStyle/>
+          <a:p>
+            <a:pPr algn="l" indent="0" marL="0">
+              <a:buNone/>
+            </a:pPr>
+            <a:r>
+              <a:rPr lang="en-US" sz="800" dirty="0">
+                <a:solidFill>
+                  <a:srgbClr val="8B93A0"/>
+                </a:solidFill>
+                <a:latin typeface="Calibri" pitchFamily="34" charset="0"/>
+                <a:ea typeface="Calibri" pitchFamily="34" charset="-122"/>
+                <a:cs typeface="Calibri" pitchFamily="34" charset="-120"/>
+              </a:rPr>
+              <a:t>DATRE CORPORATION LIMITED  |  CONFIDENTIAL — PREPARED FOR INVESTOR DISCUSSION</a:t>
+            </a:r>
+            <a:endParaRPr lang="en-US" sz="800" dirty="0"/>
+          </a:p>
+        </p:txBody>
+      </p:sp>
+      <p:sp>
+        <p:nvSpPr>
+          <p:cNvPr id="21" name="Text 19"/>
           <p:cNvSpPr/>
           <p:nvPr/>
         </p:nvSpPr>
@@ -22906,6 +23549,1194 @@
                 <a:cs typeface="Calibri" pitchFamily="34" charset="-120"/>
               </a:rPr>
               <a:t>26</a:t>
+            </a:r>
+            <a:endParaRPr lang="en-US" sz="800" dirty="0"/>
+          </a:p>
+        </p:txBody>
+      </p:sp>
+    </p:spTree>
+  </p:cSld>
+  <p:clrMapOvr>
+    <a:masterClrMapping/>
+  </p:clrMapOvr>
+</p:sld>
+</file>
+
+<file path=ppt/slides/slide27.xml><?xml version="1.0" encoding="utf-8"?>
+<p:sld xmlns:a="http://schemas.openxmlformats.org/drawingml/2006/main" xmlns:r="http://schemas.openxmlformats.org/officeDocument/2006/relationships" xmlns:p="http://schemas.openxmlformats.org/presentationml/2006/main">
+  <p:cSld name="Slide 27">
+    <p:bg>
+      <p:bgPr>
+        <a:solidFill>
+          <a:srgbClr val="1C1F26"/>
+        </a:solidFill>
+      </p:bgPr>
+    </p:bg>
+    <p:spTree>
+      <p:nvGrpSpPr>
+        <p:cNvPr id="1" name=""/>
+        <p:cNvGrpSpPr/>
+        <p:nvPr/>
+      </p:nvGrpSpPr>
+      <p:grpSpPr>
+        <a:xfrm>
+          <a:off x="0" y="0"/>
+          <a:ext cx="0" cy="0"/>
+          <a:chOff x="0" y="0"/>
+          <a:chExt cx="0" cy="0"/>
+        </a:xfrm>
+      </p:grpSpPr>
+      <p:sp>
+        <p:nvSpPr>
+          <p:cNvPr id="2" name="Text 0"/>
+          <p:cNvSpPr/>
+          <p:nvPr/>
+        </p:nvSpPr>
+        <p:spPr>
+          <a:xfrm>
+            <a:off x="548640" y="457200"/>
+            <a:ext cx="4572000" cy="274320"/>
+          </a:xfrm>
+          <a:prstGeom prst="rect">
+            <a:avLst/>
+          </a:prstGeom>
+          <a:noFill/>
+          <a:ln/>
+        </p:spPr>
+        <p:txBody>
+          <a:bodyPr wrap="square" lIns="0" tIns="0" rIns="0" bIns="0" rtlCol="0" anchor="ctr"/>
+          <a:lstStyle/>
+          <a:p>
+            <a:pPr indent="0" marL="0">
+              <a:buNone/>
+            </a:pPr>
+            <a:r>
+              <a:rPr lang="en-US" sz="1100" b="1" spc="200" kern="0" dirty="0">
+                <a:solidFill>
+                  <a:srgbClr val="D9622B"/>
+                </a:solidFill>
+                <a:latin typeface="Calibri" pitchFamily="34" charset="0"/>
+                <a:ea typeface="Calibri" pitchFamily="34" charset="-122"/>
+                <a:cs typeface="Calibri" pitchFamily="34" charset="-120"/>
+              </a:rPr>
+              <a:t>INVESTMENT CONSIDERATIONS</a:t>
+            </a:r>
+            <a:endParaRPr lang="en-US" sz="1100" dirty="0"/>
+          </a:p>
+        </p:txBody>
+      </p:sp>
+      <p:sp>
+        <p:nvSpPr>
+          <p:cNvPr id="3" name="Text 1"/>
+          <p:cNvSpPr/>
+          <p:nvPr/>
+        </p:nvSpPr>
+        <p:spPr>
+          <a:xfrm>
+            <a:off x="548640" y="841248"/>
+            <a:ext cx="11094415" cy="685800"/>
+          </a:xfrm>
+          <a:prstGeom prst="rect">
+            <a:avLst/>
+          </a:prstGeom>
+          <a:noFill/>
+          <a:ln/>
+        </p:spPr>
+        <p:txBody>
+          <a:bodyPr wrap="square" lIns="0" tIns="0" rIns="0" bIns="0" rtlCol="0" anchor="ctr"/>
+          <a:lstStyle/>
+          <a:p>
+            <a:pPr algn="l" indent="0" marL="0">
+              <a:buNone/>
+            </a:pPr>
+            <a:r>
+              <a:rPr lang="en-US" sz="3000" b="1" dirty="0">
+                <a:solidFill>
+                  <a:srgbClr val="FFFFFF"/>
+                </a:solidFill>
+                <a:latin typeface="Cambria" pitchFamily="34" charset="0"/>
+                <a:ea typeface="Cambria" pitchFamily="34" charset="-122"/>
+                <a:cs typeface="Cambria" pitchFamily="34" charset="-120"/>
+              </a:rPr>
+              <a:t>A framework for the ask — terms to be finalized with management</a:t>
+            </a:r>
+            <a:endParaRPr lang="en-US" sz="3000" dirty="0"/>
+          </a:p>
+        </p:txBody>
+      </p:sp>
+      <p:sp>
+        <p:nvSpPr>
+          <p:cNvPr id="4" name="Shape 2"/>
+          <p:cNvSpPr/>
+          <p:nvPr/>
+        </p:nvSpPr>
+        <p:spPr>
+          <a:xfrm>
+            <a:off x="548640" y="1783080"/>
+            <a:ext cx="11094415" cy="685800"/>
+          </a:xfrm>
+          <a:prstGeom prst="roundRect">
+            <a:avLst>
+              <a:gd name="adj" fmla="val 8000"/>
+            </a:avLst>
+          </a:prstGeom>
+          <a:solidFill>
+            <a:srgbClr val="262B34"/>
+          </a:solidFill>
+          <a:ln/>
+        </p:spPr>
+      </p:sp>
+      <p:sp>
+        <p:nvSpPr>
+          <p:cNvPr id="5" name="Text 3"/>
+          <p:cNvSpPr/>
+          <p:nvPr/>
+        </p:nvSpPr>
+        <p:spPr>
+          <a:xfrm>
+            <a:off x="777240" y="1783080"/>
+            <a:ext cx="10637215" cy="685800"/>
+          </a:xfrm>
+          <a:prstGeom prst="rect">
+            <a:avLst/>
+          </a:prstGeom>
+          <a:noFill/>
+          <a:ln/>
+        </p:spPr>
+        <p:txBody>
+          <a:bodyPr wrap="square" lIns="0" tIns="0" rIns="0" bIns="0" rtlCol="0" anchor="ctr"/>
+          <a:lstStyle/>
+          <a:p>
+            <a:pPr indent="0" marL="0">
+              <a:lnSpc>
+                <a:spcPct val="110000"/>
+              </a:lnSpc>
+              <a:buNone/>
+            </a:pPr>
+            <a:r>
+              <a:rPr lang="en-US" sz="1030" i="1" dirty="0">
+                <a:solidFill>
+                  <a:srgbClr val="E8B84B"/>
+                </a:solidFill>
+                <a:latin typeface="Calibri" pitchFamily="34" charset="0"/>
+                <a:ea typeface="Calibri" pitchFamily="34" charset="-122"/>
+                <a:cs typeface="Calibri" pitchFamily="34" charset="-120"/>
+              </a:rPr>
+              <a:t>The materials reviewed do not specify a funding quantum, instrument, valuation or use-of-proceeds. What follows is a suggested framework, derived from the financial and operational analysis in this deck — not a management-approved ask.</a:t>
+            </a:r>
+            <a:endParaRPr lang="en-US" sz="1030" dirty="0"/>
+          </a:p>
+        </p:txBody>
+      </p:sp>
+      <p:sp>
+        <p:nvSpPr>
+          <p:cNvPr id="6" name="Shape 4"/>
+          <p:cNvSpPr/>
+          <p:nvPr/>
+        </p:nvSpPr>
+        <p:spPr>
+          <a:xfrm>
+            <a:off x="548640" y="2788920"/>
+            <a:ext cx="457200" cy="457200"/>
+          </a:xfrm>
+          <a:prstGeom prst="ellipse">
+            <a:avLst/>
+          </a:prstGeom>
+          <a:solidFill>
+            <a:srgbClr val="D9622B"/>
+          </a:solidFill>
+          <a:ln/>
+        </p:spPr>
+      </p:sp>
+      <p:sp>
+        <p:nvSpPr>
+          <p:cNvPr id="7" name="Text 5"/>
+          <p:cNvSpPr/>
+          <p:nvPr/>
+        </p:nvSpPr>
+        <p:spPr>
+          <a:xfrm>
+            <a:off x="548640" y="2788920"/>
+            <a:ext cx="457200" cy="457200"/>
+          </a:xfrm>
+          <a:prstGeom prst="rect">
+            <a:avLst/>
+          </a:prstGeom>
+          <a:noFill/>
+          <a:ln/>
+        </p:spPr>
+        <p:txBody>
+          <a:bodyPr wrap="square" lIns="0" tIns="0" rIns="0" bIns="0" rtlCol="0" anchor="ctr"/>
+          <a:lstStyle/>
+          <a:p>
+            <a:pPr algn="ctr" indent="0" marL="0">
+              <a:buNone/>
+            </a:pPr>
+            <a:r>
+              <a:rPr lang="en-US" sz="1300" b="1" dirty="0">
+                <a:solidFill>
+                  <a:srgbClr val="FFFFFF"/>
+                </a:solidFill>
+                <a:latin typeface="Calibri" pitchFamily="34" charset="0"/>
+                <a:ea typeface="Calibri" pitchFamily="34" charset="-122"/>
+                <a:cs typeface="Calibri" pitchFamily="34" charset="-120"/>
+              </a:rPr>
+              <a:t>1</a:t>
+            </a:r>
+            <a:endParaRPr lang="en-US" sz="1300" dirty="0"/>
+          </a:p>
+        </p:txBody>
+      </p:sp>
+      <p:sp>
+        <p:nvSpPr>
+          <p:cNvPr id="8" name="Text 6"/>
+          <p:cNvSpPr/>
+          <p:nvPr/>
+        </p:nvSpPr>
+        <p:spPr>
+          <a:xfrm>
+            <a:off x="1234440" y="2770632"/>
+            <a:ext cx="2926080" cy="502920"/>
+          </a:xfrm>
+          <a:prstGeom prst="rect">
+            <a:avLst/>
+          </a:prstGeom>
+          <a:noFill/>
+          <a:ln/>
+        </p:spPr>
+        <p:txBody>
+          <a:bodyPr wrap="square" lIns="0" tIns="0" rIns="0" bIns="0" rtlCol="0" anchor="ctr"/>
+          <a:lstStyle/>
+          <a:p>
+            <a:pPr indent="0" marL="0">
+              <a:lnSpc>
+                <a:spcPct val="100000"/>
+              </a:lnSpc>
+              <a:buNone/>
+            </a:pPr>
+            <a:r>
+              <a:rPr lang="en-US" sz="1300" b="1" dirty="0">
+                <a:solidFill>
+                  <a:srgbClr val="FFFFFF"/>
+                </a:solidFill>
+                <a:latin typeface="Calibri" pitchFamily="34" charset="0"/>
+                <a:ea typeface="Calibri" pitchFamily="34" charset="-122"/>
+                <a:cs typeface="Calibri" pitchFamily="34" charset="-120"/>
+              </a:rPr>
+              <a:t>Balance-sheet repair</a:t>
+            </a:r>
+            <a:endParaRPr lang="en-US" sz="1300" dirty="0"/>
+          </a:p>
+        </p:txBody>
+      </p:sp>
+      <p:sp>
+        <p:nvSpPr>
+          <p:cNvPr id="9" name="Text 7"/>
+          <p:cNvSpPr/>
+          <p:nvPr/>
+        </p:nvSpPr>
+        <p:spPr>
+          <a:xfrm>
+            <a:off x="4297680" y="2743200"/>
+            <a:ext cx="7345375" cy="731520"/>
+          </a:xfrm>
+          <a:prstGeom prst="rect">
+            <a:avLst/>
+          </a:prstGeom>
+          <a:noFill/>
+          <a:ln/>
+        </p:spPr>
+        <p:txBody>
+          <a:bodyPr wrap="square" lIns="0" tIns="0" rIns="0" bIns="0" rtlCol="0" anchor="t"/>
+          <a:lstStyle/>
+          <a:p>
+            <a:pPr indent="0" marL="0">
+              <a:lnSpc>
+                <a:spcPct val="115000"/>
+              </a:lnSpc>
+              <a:buNone/>
+            </a:pPr>
+            <a:r>
+              <a:rPr lang="en-US" sz="1030" dirty="0">
+                <a:solidFill>
+                  <a:srgbClr val="CBD3DC"/>
+                </a:solidFill>
+                <a:latin typeface="Calibri" pitchFamily="34" charset="0"/>
+                <a:ea typeface="Calibri" pitchFamily="34" charset="-122"/>
+                <a:cs typeface="Calibri" pitchFamily="34" charset="-120"/>
+              </a:rPr>
+              <a:t>Equity infusion or a structured plan to accelerate net worth from -₹1.54 Cr (FY25) to positive, rather than relying solely on ~₹1.4 Cr/yr retained earnings.</a:t>
+            </a:r>
+            <a:endParaRPr lang="en-US" sz="1030" dirty="0"/>
+          </a:p>
+        </p:txBody>
+      </p:sp>
+      <p:sp>
+        <p:nvSpPr>
+          <p:cNvPr id="10" name="Shape 8"/>
+          <p:cNvSpPr/>
+          <p:nvPr/>
+        </p:nvSpPr>
+        <p:spPr>
+          <a:xfrm>
+            <a:off x="548640" y="3840480"/>
+            <a:ext cx="457200" cy="457200"/>
+          </a:xfrm>
+          <a:prstGeom prst="ellipse">
+            <a:avLst/>
+          </a:prstGeom>
+          <a:solidFill>
+            <a:srgbClr val="D9622B"/>
+          </a:solidFill>
+          <a:ln/>
+        </p:spPr>
+      </p:sp>
+      <p:sp>
+        <p:nvSpPr>
+          <p:cNvPr id="11" name="Text 9"/>
+          <p:cNvSpPr/>
+          <p:nvPr/>
+        </p:nvSpPr>
+        <p:spPr>
+          <a:xfrm>
+            <a:off x="548640" y="3840480"/>
+            <a:ext cx="457200" cy="457200"/>
+          </a:xfrm>
+          <a:prstGeom prst="rect">
+            <a:avLst/>
+          </a:prstGeom>
+          <a:noFill/>
+          <a:ln/>
+        </p:spPr>
+        <p:txBody>
+          <a:bodyPr wrap="square" lIns="0" tIns="0" rIns="0" bIns="0" rtlCol="0" anchor="ctr"/>
+          <a:lstStyle/>
+          <a:p>
+            <a:pPr algn="ctr" indent="0" marL="0">
+              <a:buNone/>
+            </a:pPr>
+            <a:r>
+              <a:rPr lang="en-US" sz="1300" b="1" dirty="0">
+                <a:solidFill>
+                  <a:srgbClr val="FFFFFF"/>
+                </a:solidFill>
+                <a:latin typeface="Calibri" pitchFamily="34" charset="0"/>
+                <a:ea typeface="Calibri" pitchFamily="34" charset="-122"/>
+                <a:cs typeface="Calibri" pitchFamily="34" charset="-120"/>
+              </a:rPr>
+              <a:t>2</a:t>
+            </a:r>
+            <a:endParaRPr lang="en-US" sz="1300" dirty="0"/>
+          </a:p>
+        </p:txBody>
+      </p:sp>
+      <p:sp>
+        <p:nvSpPr>
+          <p:cNvPr id="12" name="Text 10"/>
+          <p:cNvSpPr/>
+          <p:nvPr/>
+        </p:nvSpPr>
+        <p:spPr>
+          <a:xfrm>
+            <a:off x="1234440" y="3822192"/>
+            <a:ext cx="2926080" cy="502920"/>
+          </a:xfrm>
+          <a:prstGeom prst="rect">
+            <a:avLst/>
+          </a:prstGeom>
+          <a:noFill/>
+          <a:ln/>
+        </p:spPr>
+        <p:txBody>
+          <a:bodyPr wrap="square" lIns="0" tIns="0" rIns="0" bIns="0" rtlCol="0" anchor="ctr"/>
+          <a:lstStyle/>
+          <a:p>
+            <a:pPr indent="0" marL="0">
+              <a:lnSpc>
+                <a:spcPct val="100000"/>
+              </a:lnSpc>
+              <a:buNone/>
+            </a:pPr>
+            <a:r>
+              <a:rPr lang="en-US" sz="1300" b="1" dirty="0">
+                <a:solidFill>
+                  <a:srgbClr val="FFFFFF"/>
+                </a:solidFill>
+                <a:latin typeface="Calibri" pitchFamily="34" charset="0"/>
+                <a:ea typeface="Calibri" pitchFamily="34" charset="-122"/>
+                <a:cs typeface="Calibri" pitchFamily="34" charset="-120"/>
+              </a:rPr>
+              <a:t>Working-capital bridge</a:t>
+            </a:r>
+            <a:endParaRPr lang="en-US" sz="1300" dirty="0"/>
+          </a:p>
+        </p:txBody>
+      </p:sp>
+      <p:sp>
+        <p:nvSpPr>
+          <p:cNvPr id="13" name="Text 11"/>
+          <p:cNvSpPr/>
+          <p:nvPr/>
+        </p:nvSpPr>
+        <p:spPr>
+          <a:xfrm>
+            <a:off x="4297680" y="3794760"/>
+            <a:ext cx="7345375" cy="731520"/>
+          </a:xfrm>
+          <a:prstGeom prst="rect">
+            <a:avLst/>
+          </a:prstGeom>
+          <a:noFill/>
+          <a:ln/>
+        </p:spPr>
+        <p:txBody>
+          <a:bodyPr wrap="square" lIns="0" tIns="0" rIns="0" bIns="0" rtlCol="0" anchor="t"/>
+          <a:lstStyle/>
+          <a:p>
+            <a:pPr indent="0" marL="0">
+              <a:lnSpc>
+                <a:spcPct val="115000"/>
+              </a:lnSpc>
+              <a:buNone/>
+            </a:pPr>
+            <a:r>
+              <a:rPr lang="en-US" sz="1030" dirty="0">
+                <a:solidFill>
+                  <a:srgbClr val="CBD3DC"/>
+                </a:solidFill>
+                <a:latin typeface="Calibri" pitchFamily="34" charset="0"/>
+                <a:ea typeface="Calibri" pitchFamily="34" charset="-122"/>
+                <a:cs typeface="Calibri" pitchFamily="34" charset="-120"/>
+              </a:rPr>
+              <a:t>Support the Tega/Escorts receivable cycle at the ₹25-30 Cr revenue range Datre has now demonstrated it can reach.</a:t>
+            </a:r>
+            <a:endParaRPr lang="en-US" sz="1030" dirty="0"/>
+          </a:p>
+        </p:txBody>
+      </p:sp>
+      <p:sp>
+        <p:nvSpPr>
+          <p:cNvPr id="14" name="Shape 12"/>
+          <p:cNvSpPr/>
+          <p:nvPr/>
+        </p:nvSpPr>
+        <p:spPr>
+          <a:xfrm>
+            <a:off x="548640" y="4892040"/>
+            <a:ext cx="457200" cy="457200"/>
+          </a:xfrm>
+          <a:prstGeom prst="ellipse">
+            <a:avLst/>
+          </a:prstGeom>
+          <a:solidFill>
+            <a:srgbClr val="D9622B"/>
+          </a:solidFill>
+          <a:ln/>
+        </p:spPr>
+      </p:sp>
+      <p:sp>
+        <p:nvSpPr>
+          <p:cNvPr id="15" name="Text 13"/>
+          <p:cNvSpPr/>
+          <p:nvPr/>
+        </p:nvSpPr>
+        <p:spPr>
+          <a:xfrm>
+            <a:off x="548640" y="4892040"/>
+            <a:ext cx="457200" cy="457200"/>
+          </a:xfrm>
+          <a:prstGeom prst="rect">
+            <a:avLst/>
+          </a:prstGeom>
+          <a:noFill/>
+          <a:ln/>
+        </p:spPr>
+        <p:txBody>
+          <a:bodyPr wrap="square" lIns="0" tIns="0" rIns="0" bIns="0" rtlCol="0" anchor="ctr"/>
+          <a:lstStyle/>
+          <a:p>
+            <a:pPr algn="ctr" indent="0" marL="0">
+              <a:buNone/>
+            </a:pPr>
+            <a:r>
+              <a:rPr lang="en-US" sz="1300" b="1" dirty="0">
+                <a:solidFill>
+                  <a:srgbClr val="FFFFFF"/>
+                </a:solidFill>
+                <a:latin typeface="Calibri" pitchFamily="34" charset="0"/>
+                <a:ea typeface="Calibri" pitchFamily="34" charset="-122"/>
+                <a:cs typeface="Calibri" pitchFamily="34" charset="-120"/>
+              </a:rPr>
+              <a:t>3</a:t>
+            </a:r>
+            <a:endParaRPr lang="en-US" sz="1300" dirty="0"/>
+          </a:p>
+        </p:txBody>
+      </p:sp>
+      <p:sp>
+        <p:nvSpPr>
+          <p:cNvPr id="16" name="Text 14"/>
+          <p:cNvSpPr/>
+          <p:nvPr/>
+        </p:nvSpPr>
+        <p:spPr>
+          <a:xfrm>
+            <a:off x="1234440" y="4873752"/>
+            <a:ext cx="2926080" cy="502920"/>
+          </a:xfrm>
+          <a:prstGeom prst="rect">
+            <a:avLst/>
+          </a:prstGeom>
+          <a:noFill/>
+          <a:ln/>
+        </p:spPr>
+        <p:txBody>
+          <a:bodyPr wrap="square" lIns="0" tIns="0" rIns="0" bIns="0" rtlCol="0" anchor="ctr"/>
+          <a:lstStyle/>
+          <a:p>
+            <a:pPr indent="0" marL="0">
+              <a:lnSpc>
+                <a:spcPct val="100000"/>
+              </a:lnSpc>
+              <a:buNone/>
+            </a:pPr>
+            <a:r>
+              <a:rPr lang="en-US" sz="1300" b="1" dirty="0">
+                <a:solidFill>
+                  <a:srgbClr val="FFFFFF"/>
+                </a:solidFill>
+                <a:latin typeface="Calibri" pitchFamily="34" charset="0"/>
+                <a:ea typeface="Calibri" pitchFamily="34" charset="-122"/>
+                <a:cs typeface="Calibri" pitchFamily="34" charset="-120"/>
+              </a:rPr>
+              <a:t>Quality-systems investment</a:t>
+            </a:r>
+            <a:endParaRPr lang="en-US" sz="1300" dirty="0"/>
+          </a:p>
+        </p:txBody>
+      </p:sp>
+      <p:sp>
+        <p:nvSpPr>
+          <p:cNvPr id="17" name="Text 15"/>
+          <p:cNvSpPr/>
+          <p:nvPr/>
+        </p:nvSpPr>
+        <p:spPr>
+          <a:xfrm>
+            <a:off x="4297680" y="4846320"/>
+            <a:ext cx="7345375" cy="731520"/>
+          </a:xfrm>
+          <a:prstGeom prst="rect">
+            <a:avLst/>
+          </a:prstGeom>
+          <a:noFill/>
+          <a:ln/>
+        </p:spPr>
+        <p:txBody>
+          <a:bodyPr wrap="square" lIns="0" tIns="0" rIns="0" bIns="0" rtlCol="0" anchor="t"/>
+          <a:lstStyle/>
+          <a:p>
+            <a:pPr indent="0" marL="0">
+              <a:lnSpc>
+                <a:spcPct val="115000"/>
+              </a:lnSpc>
+              <a:buNone/>
+            </a:pPr>
+            <a:r>
+              <a:rPr lang="en-US" sz="1030" dirty="0">
+                <a:solidFill>
+                  <a:srgbClr val="CBD3DC"/>
+                </a:solidFill>
+                <a:latin typeface="Calibri" pitchFamily="34" charset="0"/>
+                <a:ea typeface="Calibri" pitchFamily="34" charset="-122"/>
+                <a:cs typeface="Calibri" pitchFamily="34" charset="-120"/>
+              </a:rPr>
+              <a:t>Targeted spend to bring the rejection rate back toward its FY22-23 low (~2.6%) — scrap-cost savings alone should fund a meaningful share of this.</a:t>
+            </a:r>
+            <a:endParaRPr lang="en-US" sz="1030" dirty="0"/>
+          </a:p>
+        </p:txBody>
+      </p:sp>
+      <p:sp>
+        <p:nvSpPr>
+          <p:cNvPr id="18" name="Text 16"/>
+          <p:cNvSpPr/>
+          <p:nvPr/>
+        </p:nvSpPr>
+        <p:spPr>
+          <a:xfrm>
+            <a:off x="548640" y="5989320"/>
+            <a:ext cx="11094415" cy="457200"/>
+          </a:xfrm>
+          <a:prstGeom prst="rect">
+            <a:avLst/>
+          </a:prstGeom>
+          <a:noFill/>
+          <a:ln/>
+        </p:spPr>
+        <p:txBody>
+          <a:bodyPr wrap="square" lIns="0" tIns="0" rIns="0" bIns="0" rtlCol="0" anchor="ctr"/>
+          <a:lstStyle/>
+          <a:p>
+            <a:pPr indent="0" marL="0">
+              <a:lnSpc>
+                <a:spcPct val="110000"/>
+              </a:lnSpc>
+              <a:buNone/>
+            </a:pPr>
+            <a:r>
+              <a:rPr lang="en-US" sz="950" i="1" dirty="0">
+                <a:solidFill>
+                  <a:srgbClr val="9AA2AD"/>
+                </a:solidFill>
+                <a:latin typeface="Calibri" pitchFamily="34" charset="0"/>
+                <a:ea typeface="Calibri" pitchFamily="34" charset="-122"/>
+                <a:cs typeface="Calibri" pitchFamily="34" charset="-120"/>
+              </a:rPr>
+              <a:t>Any of the three should be sized against audited FY25 and FY25-26 management accounts, not the figures in this deck alone — and against resolution of the governance flags on slide 14.</a:t>
+            </a:r>
+            <a:endParaRPr lang="en-US" sz="950" dirty="0"/>
+          </a:p>
+        </p:txBody>
+      </p:sp>
+      <p:sp>
+        <p:nvSpPr>
+          <p:cNvPr id="19" name="Text 17"/>
+          <p:cNvSpPr/>
+          <p:nvPr/>
+        </p:nvSpPr>
+        <p:spPr>
+          <a:xfrm>
+            <a:off x="548640" y="6473952"/>
+            <a:ext cx="11094415" cy="274320"/>
+          </a:xfrm>
+          <a:prstGeom prst="rect">
+            <a:avLst/>
+          </a:prstGeom>
+          <a:noFill/>
+          <a:ln/>
+        </p:spPr>
+        <p:txBody>
+          <a:bodyPr wrap="square" lIns="0" tIns="0" rIns="0" bIns="0" rtlCol="0" anchor="ctr"/>
+          <a:lstStyle/>
+          <a:p>
+            <a:pPr algn="l" indent="0" marL="0">
+              <a:buNone/>
+            </a:pPr>
+            <a:r>
+              <a:rPr lang="en-US" sz="800" dirty="0">
+                <a:solidFill>
+                  <a:srgbClr val="8B93A0"/>
+                </a:solidFill>
+                <a:latin typeface="Calibri" pitchFamily="34" charset="0"/>
+                <a:ea typeface="Calibri" pitchFamily="34" charset="-122"/>
+                <a:cs typeface="Calibri" pitchFamily="34" charset="-120"/>
+              </a:rPr>
+              <a:t>DATRE CORPORATION LIMITED  |  CONFIDENTIAL — PREPARED FOR INVESTOR DISCUSSION</a:t>
+            </a:r>
+            <a:endParaRPr lang="en-US" sz="800" dirty="0"/>
+          </a:p>
+        </p:txBody>
+      </p:sp>
+      <p:sp>
+        <p:nvSpPr>
+          <p:cNvPr id="20" name="Text 18"/>
+          <p:cNvSpPr/>
+          <p:nvPr/>
+        </p:nvSpPr>
+        <p:spPr>
+          <a:xfrm>
+            <a:off x="11277295" y="6473952"/>
+            <a:ext cx="457200" cy="274320"/>
+          </a:xfrm>
+          <a:prstGeom prst="rect">
+            <a:avLst/>
+          </a:prstGeom>
+          <a:noFill/>
+          <a:ln/>
+        </p:spPr>
+        <p:txBody>
+          <a:bodyPr wrap="square" lIns="0" tIns="0" rIns="0" bIns="0" rtlCol="0" anchor="ctr"/>
+          <a:lstStyle/>
+          <a:p>
+            <a:pPr algn="r" indent="0" marL="0">
+              <a:buNone/>
+            </a:pPr>
+            <a:r>
+              <a:rPr lang="en-US" sz="800" dirty="0">
+                <a:solidFill>
+                  <a:srgbClr val="8B93A0"/>
+                </a:solidFill>
+                <a:latin typeface="Calibri" pitchFamily="34" charset="0"/>
+                <a:ea typeface="Calibri" pitchFamily="34" charset="-122"/>
+                <a:cs typeface="Calibri" pitchFamily="34" charset="-120"/>
+              </a:rPr>
+              <a:t>27</a:t>
+            </a:r>
+            <a:endParaRPr lang="en-US" sz="800" dirty="0"/>
+          </a:p>
+        </p:txBody>
+      </p:sp>
+    </p:spTree>
+  </p:cSld>
+  <p:clrMapOvr>
+    <a:masterClrMapping/>
+  </p:clrMapOvr>
+</p:sld>
+</file>
+
+<file path=ppt/slides/slide28.xml><?xml version="1.0" encoding="utf-8"?>
+<p:sld xmlns:a="http://schemas.openxmlformats.org/drawingml/2006/main" xmlns:r="http://schemas.openxmlformats.org/officeDocument/2006/relationships" xmlns:p="http://schemas.openxmlformats.org/presentationml/2006/main">
+  <p:cSld name="Slide 28">
+    <p:bg>
+      <p:bgPr>
+        <a:solidFill>
+          <a:srgbClr val="1C1F26"/>
+        </a:solidFill>
+      </p:bgPr>
+    </p:bg>
+    <p:spTree>
+      <p:nvGrpSpPr>
+        <p:cNvPr id="1" name=""/>
+        <p:cNvGrpSpPr/>
+        <p:nvPr/>
+      </p:nvGrpSpPr>
+      <p:grpSpPr>
+        <a:xfrm>
+          <a:off x="0" y="0"/>
+          <a:ext cx="0" cy="0"/>
+          <a:chOff x="0" y="0"/>
+          <a:chExt cx="0" cy="0"/>
+        </a:xfrm>
+      </p:grpSpPr>
+      <p:sp>
+        <p:nvSpPr>
+          <p:cNvPr id="2" name="Shape 0"/>
+          <p:cNvSpPr/>
+          <p:nvPr/>
+        </p:nvSpPr>
+        <p:spPr>
+          <a:xfrm>
+            <a:off x="9692640" y="-1280160"/>
+            <a:ext cx="4754880" cy="4754880"/>
+          </a:xfrm>
+          <a:prstGeom prst="ellipse">
+            <a:avLst/>
+          </a:prstGeom>
+          <a:solidFill>
+            <a:srgbClr val="262B34"/>
+          </a:solidFill>
+          <a:ln/>
+        </p:spPr>
+      </p:sp>
+      <p:sp>
+        <p:nvSpPr>
+          <p:cNvPr id="3" name="Shape 1"/>
+          <p:cNvSpPr/>
+          <p:nvPr/>
+        </p:nvSpPr>
+        <p:spPr>
+          <a:xfrm>
+            <a:off x="-1463040" y="4572000"/>
+            <a:ext cx="3657600" cy="3657600"/>
+          </a:xfrm>
+          <a:prstGeom prst="ellipse">
+            <a:avLst/>
+          </a:prstGeom>
+          <a:solidFill>
+            <a:srgbClr val="262B34"/>
+          </a:solidFill>
+          <a:ln/>
+        </p:spPr>
+      </p:sp>
+      <p:sp>
+        <p:nvSpPr>
+          <p:cNvPr id="4" name="Text 2"/>
+          <p:cNvSpPr/>
+          <p:nvPr/>
+        </p:nvSpPr>
+        <p:spPr>
+          <a:xfrm>
+            <a:off x="548640" y="2286000"/>
+            <a:ext cx="9144000" cy="731520"/>
+          </a:xfrm>
+          <a:prstGeom prst="rect">
+            <a:avLst/>
+          </a:prstGeom>
+          <a:noFill/>
+          <a:ln/>
+        </p:spPr>
+        <p:txBody>
+          <a:bodyPr wrap="square" lIns="0" tIns="0" rIns="0" bIns="0" rtlCol="0" anchor="ctr"/>
+          <a:lstStyle/>
+          <a:p>
+            <a:pPr indent="0" marL="0">
+              <a:buNone/>
+            </a:pPr>
+            <a:r>
+              <a:rPr lang="en-US" sz="3400" b="1" dirty="0">
+                <a:solidFill>
+                  <a:srgbClr val="FFFFFF"/>
+                </a:solidFill>
+                <a:latin typeface="Cambria" pitchFamily="34" charset="0"/>
+                <a:ea typeface="Cambria" pitchFamily="34" charset="-122"/>
+                <a:cs typeface="Cambria" pitchFamily="34" charset="-120"/>
+              </a:rPr>
+              <a:t>Datre Corporation Limited</a:t>
+            </a:r>
+            <a:endParaRPr lang="en-US" sz="3400" dirty="0"/>
+          </a:p>
+        </p:txBody>
+      </p:sp>
+      <p:sp>
+        <p:nvSpPr>
+          <p:cNvPr id="5" name="Text 3"/>
+          <p:cNvSpPr/>
+          <p:nvPr/>
+        </p:nvSpPr>
+        <p:spPr>
+          <a:xfrm>
+            <a:off x="548640" y="2971800"/>
+            <a:ext cx="9144000" cy="457200"/>
+          </a:xfrm>
+          <a:prstGeom prst="rect">
+            <a:avLst/>
+          </a:prstGeom>
+          <a:noFill/>
+          <a:ln/>
+        </p:spPr>
+        <p:txBody>
+          <a:bodyPr wrap="square" lIns="0" tIns="0" rIns="0" bIns="0" rtlCol="0" anchor="ctr"/>
+          <a:lstStyle/>
+          <a:p>
+            <a:pPr indent="0" marL="0">
+              <a:buNone/>
+            </a:pPr>
+            <a:r>
+              <a:rPr lang="en-US" sz="1500" i="1" dirty="0">
+                <a:solidFill>
+                  <a:srgbClr val="CBD3DC"/>
+                </a:solidFill>
+                <a:latin typeface="Calibri" pitchFamily="34" charset="0"/>
+                <a:ea typeface="Calibri" pitchFamily="34" charset="-122"/>
+                <a:cs typeface="Calibri" pitchFamily="34" charset="-120"/>
+              </a:rPr>
+              <a:t>Engineering Essence, Manufacturing Personified</a:t>
+            </a:r>
+            <a:endParaRPr lang="en-US" sz="1500" dirty="0"/>
+          </a:p>
+        </p:txBody>
+      </p:sp>
+      <p:sp>
+        <p:nvSpPr>
+          <p:cNvPr id="6" name="Text 4"/>
+          <p:cNvSpPr/>
+          <p:nvPr/>
+        </p:nvSpPr>
+        <p:spPr>
+          <a:xfrm>
+            <a:off x="548640" y="4023360"/>
+            <a:ext cx="2743200" cy="274320"/>
+          </a:xfrm>
+          <a:prstGeom prst="rect">
+            <a:avLst/>
+          </a:prstGeom>
+          <a:noFill/>
+          <a:ln/>
+        </p:spPr>
+        <p:txBody>
+          <a:bodyPr wrap="square" lIns="0" tIns="0" rIns="0" bIns="0" rtlCol="0" anchor="ctr"/>
+          <a:lstStyle/>
+          <a:p>
+            <a:pPr indent="0" marL="0">
+              <a:buNone/>
+            </a:pPr>
+            <a:r>
+              <a:rPr lang="en-US" sz="950" b="1" spc="100" kern="0" dirty="0">
+                <a:solidFill>
+                  <a:srgbClr val="D9622B"/>
+                </a:solidFill>
+                <a:latin typeface="Calibri" pitchFamily="34" charset="0"/>
+                <a:ea typeface="Calibri" pitchFamily="34" charset="-122"/>
+                <a:cs typeface="Calibri" pitchFamily="34" charset="-120"/>
+              </a:rPr>
+              <a:t>REGISTERED OFFICE</a:t>
+            </a:r>
+            <a:endParaRPr lang="en-US" sz="950" dirty="0"/>
+          </a:p>
+        </p:txBody>
+      </p:sp>
+      <p:sp>
+        <p:nvSpPr>
+          <p:cNvPr id="7" name="Text 5"/>
+          <p:cNvSpPr/>
+          <p:nvPr/>
+        </p:nvSpPr>
+        <p:spPr>
+          <a:xfrm>
+            <a:off x="548640" y="4279392"/>
+            <a:ext cx="9144000" cy="365760"/>
+          </a:xfrm>
+          <a:prstGeom prst="rect">
+            <a:avLst/>
+          </a:prstGeom>
+          <a:noFill/>
+          <a:ln/>
+        </p:spPr>
+        <p:txBody>
+          <a:bodyPr wrap="square" lIns="0" tIns="0" rIns="0" bIns="0" rtlCol="0" anchor="ctr"/>
+          <a:lstStyle/>
+          <a:p>
+            <a:pPr indent="0" marL="0">
+              <a:buNone/>
+            </a:pPr>
+            <a:r>
+              <a:rPr lang="en-US" sz="1200" dirty="0">
+                <a:solidFill>
+                  <a:srgbClr val="FFFFFF"/>
+                </a:solidFill>
+                <a:latin typeface="Calibri" pitchFamily="34" charset="0"/>
+                <a:ea typeface="Calibri" pitchFamily="34" charset="-122"/>
+                <a:cs typeface="Calibri" pitchFamily="34" charset="-120"/>
+              </a:rPr>
+              <a:t>Sector-III, Falta Industrial Growth Centre, South 24 Parganas, West Bengal 743504, India</a:t>
+            </a:r>
+            <a:endParaRPr lang="en-US" sz="1200" dirty="0"/>
+          </a:p>
+        </p:txBody>
+      </p:sp>
+      <p:sp>
+        <p:nvSpPr>
+          <p:cNvPr id="8" name="Text 6"/>
+          <p:cNvSpPr/>
+          <p:nvPr/>
+        </p:nvSpPr>
+        <p:spPr>
+          <a:xfrm>
+            <a:off x="548640" y="4681728"/>
+            <a:ext cx="2743200" cy="274320"/>
+          </a:xfrm>
+          <a:prstGeom prst="rect">
+            <a:avLst/>
+          </a:prstGeom>
+          <a:noFill/>
+          <a:ln/>
+        </p:spPr>
+        <p:txBody>
+          <a:bodyPr wrap="square" lIns="0" tIns="0" rIns="0" bIns="0" rtlCol="0" anchor="ctr"/>
+          <a:lstStyle/>
+          <a:p>
+            <a:pPr indent="0" marL="0">
+              <a:buNone/>
+            </a:pPr>
+            <a:r>
+              <a:rPr lang="en-US" sz="950" b="1" spc="100" kern="0" dirty="0">
+                <a:solidFill>
+                  <a:srgbClr val="D9622B"/>
+                </a:solidFill>
+                <a:latin typeface="Calibri" pitchFamily="34" charset="0"/>
+                <a:ea typeface="Calibri" pitchFamily="34" charset="-122"/>
+                <a:cs typeface="Calibri" pitchFamily="34" charset="-120"/>
+              </a:rPr>
+              <a:t>CONTACT</a:t>
+            </a:r>
+            <a:endParaRPr lang="en-US" sz="950" dirty="0"/>
+          </a:p>
+        </p:txBody>
+      </p:sp>
+      <p:sp>
+        <p:nvSpPr>
+          <p:cNvPr id="9" name="Text 7"/>
+          <p:cNvSpPr/>
+          <p:nvPr/>
+        </p:nvSpPr>
+        <p:spPr>
+          <a:xfrm>
+            <a:off x="548640" y="4937760"/>
+            <a:ext cx="9144000" cy="365760"/>
+          </a:xfrm>
+          <a:prstGeom prst="rect">
+            <a:avLst/>
+          </a:prstGeom>
+          <a:noFill/>
+          <a:ln/>
+        </p:spPr>
+        <p:txBody>
+          <a:bodyPr wrap="square" lIns="0" tIns="0" rIns="0" bIns="0" rtlCol="0" anchor="ctr"/>
+          <a:lstStyle/>
+          <a:p>
+            <a:pPr indent="0" marL="0">
+              <a:buNone/>
+            </a:pPr>
+            <a:r>
+              <a:rPr lang="en-US" sz="1200" dirty="0">
+                <a:solidFill>
+                  <a:srgbClr val="FFFFFF"/>
+                </a:solidFill>
+                <a:latin typeface="Calibri" pitchFamily="34" charset="0"/>
+                <a:ea typeface="Calibri" pitchFamily="34" charset="-122"/>
+                <a:cs typeface="Calibri" pitchFamily="34" charset="-120"/>
+              </a:rPr>
+              <a:t>sales@datre.com  ·  hr@datre.com  ·  www.datre.in</a:t>
+            </a:r>
+            <a:endParaRPr lang="en-US" sz="1200" dirty="0"/>
+          </a:p>
+        </p:txBody>
+      </p:sp>
+      <p:sp>
+        <p:nvSpPr>
+          <p:cNvPr id="10" name="Text 8"/>
+          <p:cNvSpPr/>
+          <p:nvPr/>
+        </p:nvSpPr>
+        <p:spPr>
+          <a:xfrm>
+            <a:off x="548640" y="5340096"/>
+            <a:ext cx="2743200" cy="274320"/>
+          </a:xfrm>
+          <a:prstGeom prst="rect">
+            <a:avLst/>
+          </a:prstGeom>
+          <a:noFill/>
+          <a:ln/>
+        </p:spPr>
+        <p:txBody>
+          <a:bodyPr wrap="square" lIns="0" tIns="0" rIns="0" bIns="0" rtlCol="0" anchor="ctr"/>
+          <a:lstStyle/>
+          <a:p>
+            <a:pPr indent="0" marL="0">
+              <a:buNone/>
+            </a:pPr>
+            <a:r>
+              <a:rPr lang="en-US" sz="950" b="1" spc="100" kern="0" dirty="0">
+                <a:solidFill>
+                  <a:srgbClr val="D9622B"/>
+                </a:solidFill>
+                <a:latin typeface="Calibri" pitchFamily="34" charset="0"/>
+                <a:ea typeface="Calibri" pitchFamily="34" charset="-122"/>
+                <a:cs typeface="Calibri" pitchFamily="34" charset="-120"/>
+              </a:rPr>
+              <a:t>PREPARED FOR</a:t>
+            </a:r>
+            <a:endParaRPr lang="en-US" sz="950" dirty="0"/>
+          </a:p>
+        </p:txBody>
+      </p:sp>
+      <p:sp>
+        <p:nvSpPr>
+          <p:cNvPr id="11" name="Text 9"/>
+          <p:cNvSpPr/>
+          <p:nvPr/>
+        </p:nvSpPr>
+        <p:spPr>
+          <a:xfrm>
+            <a:off x="548640" y="5596128"/>
+            <a:ext cx="9144000" cy="365760"/>
+          </a:xfrm>
+          <a:prstGeom prst="rect">
+            <a:avLst/>
+          </a:prstGeom>
+          <a:noFill/>
+          <a:ln/>
+        </p:spPr>
+        <p:txBody>
+          <a:bodyPr wrap="square" lIns="0" tIns="0" rIns="0" bIns="0" rtlCol="0" anchor="ctr"/>
+          <a:lstStyle/>
+          <a:p>
+            <a:pPr indent="0" marL="0">
+              <a:buNone/>
+            </a:pPr>
+            <a:r>
+              <a:rPr lang="en-US" sz="1200" dirty="0">
+                <a:solidFill>
+                  <a:srgbClr val="FFFFFF"/>
+                </a:solidFill>
+                <a:latin typeface="Calibri" pitchFamily="34" charset="0"/>
+                <a:ea typeface="Calibri" pitchFamily="34" charset="-122"/>
+                <a:cs typeface="Calibri" pitchFamily="34" charset="-120"/>
+              </a:rPr>
+              <a:t>Investor discussion — Indranil Dutta, Chief Executive Officer</a:t>
+            </a:r>
+            <a:endParaRPr lang="en-US" sz="1200" dirty="0"/>
+          </a:p>
+        </p:txBody>
+      </p:sp>
+      <p:sp>
+        <p:nvSpPr>
+          <p:cNvPr id="12" name="Text 10"/>
+          <p:cNvSpPr/>
+          <p:nvPr/>
+        </p:nvSpPr>
+        <p:spPr>
+          <a:xfrm>
+            <a:off x="548640" y="5943600"/>
+            <a:ext cx="11094415" cy="640080"/>
+          </a:xfrm>
+          <a:prstGeom prst="rect">
+            <a:avLst/>
+          </a:prstGeom>
+          <a:noFill/>
+          <a:ln/>
+        </p:spPr>
+        <p:txBody>
+          <a:bodyPr wrap="square" lIns="0" tIns="0" rIns="0" bIns="0" rtlCol="0" anchor="ctr"/>
+          <a:lstStyle/>
+          <a:p>
+            <a:pPr indent="0" marL="0">
+              <a:lnSpc>
+                <a:spcPct val="115000"/>
+              </a:lnSpc>
+              <a:buNone/>
+            </a:pPr>
+            <a:r>
+              <a:rPr lang="en-US" sz="850" i="1" dirty="0">
+                <a:solidFill>
+                  <a:srgbClr val="7A828E"/>
+                </a:solidFill>
+                <a:latin typeface="Calibri" pitchFamily="34" charset="0"/>
+                <a:ea typeface="Calibri" pitchFamily="34" charset="-122"/>
+                <a:cs typeface="Calibri" pitchFamily="34" charset="-120"/>
+              </a:rPr>
+              <a:t>This document consolidates the company's own financial statements, management information system reports and internal analyses. Figures are sourced and dated throughout; where audited and unaudited data diverge, both are shown. Confidential — prepared for internal investor discussion only.</a:t>
+            </a:r>
+            <a:endParaRPr lang="en-US" sz="850" dirty="0"/>
+          </a:p>
+        </p:txBody>
+      </p:sp>
+      <p:sp>
+        <p:nvSpPr>
+          <p:cNvPr id="13" name="Text 11"/>
+          <p:cNvSpPr/>
+          <p:nvPr/>
+        </p:nvSpPr>
+        <p:spPr>
+          <a:xfrm>
+            <a:off x="11277295" y="6473952"/>
+            <a:ext cx="457200" cy="274320"/>
+          </a:xfrm>
+          <a:prstGeom prst="rect">
+            <a:avLst/>
+          </a:prstGeom>
+          <a:noFill/>
+          <a:ln/>
+        </p:spPr>
+        <p:txBody>
+          <a:bodyPr wrap="square" lIns="0" tIns="0" rIns="0" bIns="0" rtlCol="0" anchor="ctr"/>
+          <a:lstStyle/>
+          <a:p>
+            <a:pPr algn="r" indent="0" marL="0">
+              <a:buNone/>
+            </a:pPr>
+            <a:r>
+              <a:rPr lang="en-US" sz="800" dirty="0">
+                <a:solidFill>
+                  <a:srgbClr val="8B93A0"/>
+                </a:solidFill>
+                <a:latin typeface="Calibri" pitchFamily="34" charset="0"/>
+                <a:ea typeface="Calibri" pitchFamily="34" charset="-122"/>
+                <a:cs typeface="Calibri" pitchFamily="34" charset="-120"/>
+              </a:rPr>
+              <a:t>28</a:t>
             </a:r>
             <a:endParaRPr lang="en-US" sz="800" dirty="0"/>
           </a:p>

</xml_diff>

<commit_message>
Sharpen landscape slide with EEPC India export/tariff data
Replaces the unverified CBAM framing on the Industry Landscape slide
with a properly sourced finding from an EEPC India Panel 20/21
export-council agenda (18 Aug 2025) found in the CEO Speaks Drive
folder: CBAM's 50-tonne/year de-minimis gives Indian exporters "no
real relief," and a US tariff stack (25% reciprocal + 25% punitive on
top of an existing 50% Section 232 steel duty) took effect 27 Aug
2025. Drops the earlier unverified "North America-leaning exports,
not yet a direct hit" framing, which this new information supersedes,
and flags Datre's own direct or Tega-mediated US exposure as
unconfirmed rather than asserting either way.

Co-Authored-By: Claude Sonnet 5 <noreply@anthropic.com>
Claude-Session: https://claude.ai/code/session_01KAt6XMpnq79QzphizNAsgo
</commit_message>
<xml_diff>
--- a/investor-pitch/Datre_Corporation_Investor_Pitch.pptx
+++ b/investor-pitch/Datre_Corporation_Investor_Pitch.pptx
@@ -22190,7 +22190,7 @@
                 <a:ea typeface="Calibri" pitchFamily="34" charset="-122"/>
                 <a:cs typeface="Calibri" pitchFamily="34" charset="-120"/>
               </a:rPr>
-              <a:t>Carbon intensity is arriving as a new compliance layer on top of accreditation: the EU's CBAM applies a 38.8% levy above 1.5 tCO2/t since Jan 2026, against an Indian foundry baseline of 1.8-2.2 tCO2/t. Not yet a direct hit for Datre's Japan/Australia/North America-leaning exports, but increasingly an OEM supplier-audit question.</a:t>
+              <a:t>Two trade shocks now compound the compliance layer: CBAM's 50-tonne/year de-minimis gives ‘no real relief’ to most Indian exporters (EEPC India, Aug 2025), and a fresh US tariff stack — 25% reciprocal + 25% punitive atop an existing 50% Section 232 steel duty — took effect 27 Aug 2025. Datre's own direct or Tega-mediated US exposure is unconfirmed in the materials reviewed.</a:t>
             </a:r>
             <a:endParaRPr lang="en-US" sz="980" dirty="0"/>
           </a:p>
@@ -22232,7 +22232,7 @@
                 <a:ea typeface="Calibri" pitchFamily="34" charset="-122"/>
                 <a:cs typeface="Calibri" pitchFamily="34" charset="-120"/>
               </a:rPr>
-              <a:t>Sector figures (unit counts, coke pricing, CBAM threshold, consumption growth) are from an external industry briefing, not independently verified against Drive records — attributed as market context, not audited fact.</a:t>
+              <a:t>Unit counts, coke pricing and consumption growth are from an external industry briefing, unverified against Drive. The CBAM and US-tariff figures are sourced to an EEPC India Panel 20/21 export-council agenda (18 Aug 2025) found in Drive.</a:t>
             </a:r>
             <a:endParaRPr lang="en-US" sz="800" dirty="0"/>
           </a:p>

</xml_diff>